<commit_message>
Phase 4: svg_fix + pptx_fix postprocessors, design_code+layout_code connected to designer
</commit_message>
<xml_diff>
--- a/output/redesigned_test_maps.pptx
+++ b/output/redesigned_test_maps.pptx
@@ -5,11 +5,11 @@
     <p:sldMasterId id="2147483648" r:id="rId1"/>
   </p:sldMasterIdLst>
   <p:sldIdLst>
-    <p:sldId id="256" r:id="rId2"/>
-    <p:sldId id="257" r:id="rId3"/>
-    <p:sldId id="258" r:id="rId4"/>
+    <p:sldId id="256" r:id="rId7"/>
+    <p:sldId id="257" r:id="rId8"/>
+    <p:sldId id="258" r:id="rId9"/>
   </p:sldIdLst>
-  <p:sldSz cx="12192000" cy="6858000"/>
+  <p:sldSz cx="12192000" cy="6858000" type="screen4x3"/>
   <p:notesSz cx="6858000" cy="9144000"/>
   <p:defaultTextStyle>
     <a:defPPr>
@@ -106,22 +106,6 @@
       </a:defRPr>
     </a:lvl9pPr>
   </p:defaultTextStyle>
-  <p:extLst>
-    <p:ext uri="{EFAFB233-063F-42B5-8137-9DF3F51BA10A}">
-      <p15:sldGuideLst xmlns:p15="http://schemas.microsoft.com/office/powerpoint/2012/main">
-        <p15:guide id="1" orient="horz" pos="2160">
-          <p15:clr>
-            <a:srgbClr val="A4A3A4"/>
-          </p15:clr>
-        </p15:guide>
-        <p15:guide id="2" pos="2880">
-          <p15:clr>
-            <a:srgbClr val="A4A3A4"/>
-          </p15:clr>
-        </p15:guide>
-      </p15:sldGuideLst>
-    </p:ext>
-  </p:extLst>
 </p:presentation>
 </file>
 
@@ -163,9 +147,10 @@
           <a:lstStyle/>
           <a:p>
             <a:r>
-              <a:rPr lang="en-US"/>
+              <a:rPr lang="en-US" smtClean="0"/>
               <a:t>Click to edit Master title style</a:t>
             </a:r>
+            <a:endParaRPr lang="en-US"/>
           </a:p>
         </p:txBody>
       </p:sp>
@@ -281,9 +266,10 @@
           </a:lstStyle>
           <a:p>
             <a:r>
-              <a:rPr lang="en-US"/>
+              <a:rPr lang="en-US" smtClean="0"/>
               <a:t>Click to edit Master subtitle style</a:t>
             </a:r>
+            <a:endParaRPr lang="en-US"/>
           </a:p>
         </p:txBody>
       </p:sp>
@@ -304,7 +290,7 @@
           <a:p>
             <a:fld id="{5BCAD085-E8A6-8845-BD4E-CB4CCA059FC4}" type="datetimeFigureOut">
               <a:rPr lang="en-US" smtClean="0"/>
-              <a:t>4/30/2026</a:t>
+              <a:t>1/27/13</a:t>
             </a:fld>
             <a:endParaRPr lang="en-US"/>
           </a:p>
@@ -398,9 +384,10 @@
           <a:lstStyle/>
           <a:p>
             <a:r>
-              <a:rPr lang="en-US"/>
+              <a:rPr lang="en-US" smtClean="0"/>
               <a:t>Click to edit Master title style</a:t>
             </a:r>
+            <a:endParaRPr lang="en-US"/>
           </a:p>
         </p:txBody>
       </p:sp>
@@ -421,37 +408,38 @@
           <a:p>
             <a:pPr lvl="0"/>
             <a:r>
-              <a:rPr lang="en-US"/>
+              <a:rPr lang="en-US" smtClean="0"/>
               <a:t>Click to edit Master text styles</a:t>
             </a:r>
           </a:p>
           <a:p>
             <a:pPr lvl="1"/>
             <a:r>
-              <a:rPr lang="en-US"/>
+              <a:rPr lang="en-US" smtClean="0"/>
               <a:t>Second level</a:t>
             </a:r>
           </a:p>
           <a:p>
             <a:pPr lvl="2"/>
             <a:r>
-              <a:rPr lang="en-US"/>
+              <a:rPr lang="en-US" smtClean="0"/>
               <a:t>Third level</a:t>
             </a:r>
           </a:p>
           <a:p>
             <a:pPr lvl="3"/>
             <a:r>
-              <a:rPr lang="en-US"/>
+              <a:rPr lang="en-US" smtClean="0"/>
               <a:t>Fourth level</a:t>
             </a:r>
           </a:p>
           <a:p>
             <a:pPr lvl="4"/>
             <a:r>
-              <a:rPr lang="en-US"/>
+              <a:rPr lang="en-US" smtClean="0"/>
               <a:t>Fifth level</a:t>
             </a:r>
+            <a:endParaRPr lang="en-US"/>
           </a:p>
         </p:txBody>
       </p:sp>
@@ -472,7 +460,7 @@
           <a:p>
             <a:fld id="{5BCAD085-E8A6-8845-BD4E-CB4CCA059FC4}" type="datetimeFigureOut">
               <a:rPr lang="en-US" smtClean="0"/>
-              <a:t>4/30/2026</a:t>
+              <a:t>1/27/13</a:t>
             </a:fld>
             <a:endParaRPr lang="en-US"/>
           </a:p>
@@ -571,9 +559,10 @@
           <a:lstStyle/>
           <a:p>
             <a:r>
-              <a:rPr lang="en-US"/>
+              <a:rPr lang="en-US" smtClean="0"/>
               <a:t>Click to edit Master title style</a:t>
             </a:r>
+            <a:endParaRPr lang="en-US"/>
           </a:p>
         </p:txBody>
       </p:sp>
@@ -599,37 +588,38 @@
           <a:p>
             <a:pPr lvl="0"/>
             <a:r>
-              <a:rPr lang="en-US"/>
+              <a:rPr lang="en-US" smtClean="0"/>
               <a:t>Click to edit Master text styles</a:t>
             </a:r>
           </a:p>
           <a:p>
             <a:pPr lvl="1"/>
             <a:r>
-              <a:rPr lang="en-US"/>
+              <a:rPr lang="en-US" smtClean="0"/>
               <a:t>Second level</a:t>
             </a:r>
           </a:p>
           <a:p>
             <a:pPr lvl="2"/>
             <a:r>
-              <a:rPr lang="en-US"/>
+              <a:rPr lang="en-US" smtClean="0"/>
               <a:t>Third level</a:t>
             </a:r>
           </a:p>
           <a:p>
             <a:pPr lvl="3"/>
             <a:r>
-              <a:rPr lang="en-US"/>
+              <a:rPr lang="en-US" smtClean="0"/>
               <a:t>Fourth level</a:t>
             </a:r>
           </a:p>
           <a:p>
             <a:pPr lvl="4"/>
             <a:r>
-              <a:rPr lang="en-US"/>
+              <a:rPr lang="en-US" smtClean="0"/>
               <a:t>Fifth level</a:t>
             </a:r>
+            <a:endParaRPr lang="en-US"/>
           </a:p>
         </p:txBody>
       </p:sp>
@@ -650,7 +640,7 @@
           <a:p>
             <a:fld id="{5BCAD085-E8A6-8845-BD4E-CB4CCA059FC4}" type="datetimeFigureOut">
               <a:rPr lang="en-US" smtClean="0"/>
-              <a:t>4/30/2026</a:t>
+              <a:t>1/27/13</a:t>
             </a:fld>
             <a:endParaRPr lang="en-US"/>
           </a:p>
@@ -744,9 +734,10 @@
           <a:lstStyle/>
           <a:p>
             <a:r>
-              <a:rPr lang="en-US"/>
+              <a:rPr lang="en-US" smtClean="0"/>
               <a:t>Click to edit Master title style</a:t>
             </a:r>
+            <a:endParaRPr lang="en-US"/>
           </a:p>
         </p:txBody>
       </p:sp>
@@ -767,37 +758,38 @@
           <a:p>
             <a:pPr lvl="0"/>
             <a:r>
-              <a:rPr lang="en-US"/>
+              <a:rPr lang="en-US" smtClean="0"/>
               <a:t>Click to edit Master text styles</a:t>
             </a:r>
           </a:p>
           <a:p>
             <a:pPr lvl="1"/>
             <a:r>
-              <a:rPr lang="en-US"/>
+              <a:rPr lang="en-US" smtClean="0"/>
               <a:t>Second level</a:t>
             </a:r>
           </a:p>
           <a:p>
             <a:pPr lvl="2"/>
             <a:r>
-              <a:rPr lang="en-US"/>
+              <a:rPr lang="en-US" smtClean="0"/>
               <a:t>Third level</a:t>
             </a:r>
           </a:p>
           <a:p>
             <a:pPr lvl="3"/>
             <a:r>
-              <a:rPr lang="en-US"/>
+              <a:rPr lang="en-US" smtClean="0"/>
               <a:t>Fourth level</a:t>
             </a:r>
           </a:p>
           <a:p>
             <a:pPr lvl="4"/>
             <a:r>
-              <a:rPr lang="en-US"/>
+              <a:rPr lang="en-US" smtClean="0"/>
               <a:t>Fifth level</a:t>
             </a:r>
+            <a:endParaRPr lang="en-US"/>
           </a:p>
         </p:txBody>
       </p:sp>
@@ -818,7 +810,7 @@
           <a:p>
             <a:fld id="{5BCAD085-E8A6-8845-BD4E-CB4CCA059FC4}" type="datetimeFigureOut">
               <a:rPr lang="en-US" smtClean="0"/>
-              <a:t>4/30/2026</a:t>
+              <a:t>1/27/13</a:t>
             </a:fld>
             <a:endParaRPr lang="en-US"/>
           </a:p>
@@ -921,9 +913,10 @@
           </a:lstStyle>
           <a:p>
             <a:r>
-              <a:rPr lang="en-US"/>
+              <a:rPr lang="en-US" smtClean="0"/>
               <a:t>Click to edit Master title style</a:t>
             </a:r>
+            <a:endParaRPr lang="en-US"/>
           </a:p>
         </p:txBody>
       </p:sp>
@@ -1040,7 +1033,7 @@
           <a:p>
             <a:pPr lvl="0"/>
             <a:r>
-              <a:rPr lang="en-US"/>
+              <a:rPr lang="en-US" smtClean="0"/>
               <a:t>Click to edit Master text styles</a:t>
             </a:r>
           </a:p>
@@ -1063,7 +1056,7 @@
           <a:p>
             <a:fld id="{5BCAD085-E8A6-8845-BD4E-CB4CCA059FC4}" type="datetimeFigureOut">
               <a:rPr lang="en-US" smtClean="0"/>
-              <a:t>4/30/2026</a:t>
+              <a:t>1/27/13</a:t>
             </a:fld>
             <a:endParaRPr lang="en-US"/>
           </a:p>
@@ -1157,9 +1150,10 @@
           <a:lstStyle/>
           <a:p>
             <a:r>
-              <a:rPr lang="en-US"/>
+              <a:rPr lang="en-US" smtClean="0"/>
               <a:t>Click to edit Master title style</a:t>
             </a:r>
+            <a:endParaRPr lang="en-US"/>
           </a:p>
         </p:txBody>
       </p:sp>
@@ -1213,37 +1207,38 @@
           <a:p>
             <a:pPr lvl="0"/>
             <a:r>
-              <a:rPr lang="en-US"/>
+              <a:rPr lang="en-US" smtClean="0"/>
               <a:t>Click to edit Master text styles</a:t>
             </a:r>
           </a:p>
           <a:p>
             <a:pPr lvl="1"/>
             <a:r>
-              <a:rPr lang="en-US"/>
+              <a:rPr lang="en-US" smtClean="0"/>
               <a:t>Second level</a:t>
             </a:r>
           </a:p>
           <a:p>
             <a:pPr lvl="2"/>
             <a:r>
-              <a:rPr lang="en-US"/>
+              <a:rPr lang="en-US" smtClean="0"/>
               <a:t>Third level</a:t>
             </a:r>
           </a:p>
           <a:p>
             <a:pPr lvl="3"/>
             <a:r>
-              <a:rPr lang="en-US"/>
+              <a:rPr lang="en-US" smtClean="0"/>
               <a:t>Fourth level</a:t>
             </a:r>
           </a:p>
           <a:p>
             <a:pPr lvl="4"/>
             <a:r>
-              <a:rPr lang="en-US"/>
+              <a:rPr lang="en-US" smtClean="0"/>
               <a:t>Fifth level</a:t>
             </a:r>
+            <a:endParaRPr lang="en-US"/>
           </a:p>
         </p:txBody>
       </p:sp>
@@ -1297,37 +1292,38 @@
           <a:p>
             <a:pPr lvl="0"/>
             <a:r>
-              <a:rPr lang="en-US"/>
+              <a:rPr lang="en-US" smtClean="0"/>
               <a:t>Click to edit Master text styles</a:t>
             </a:r>
           </a:p>
           <a:p>
             <a:pPr lvl="1"/>
             <a:r>
-              <a:rPr lang="en-US"/>
+              <a:rPr lang="en-US" smtClean="0"/>
               <a:t>Second level</a:t>
             </a:r>
           </a:p>
           <a:p>
             <a:pPr lvl="2"/>
             <a:r>
-              <a:rPr lang="en-US"/>
+              <a:rPr lang="en-US" smtClean="0"/>
               <a:t>Third level</a:t>
             </a:r>
           </a:p>
           <a:p>
             <a:pPr lvl="3"/>
             <a:r>
-              <a:rPr lang="en-US"/>
+              <a:rPr lang="en-US" smtClean="0"/>
               <a:t>Fourth level</a:t>
             </a:r>
           </a:p>
           <a:p>
             <a:pPr lvl="4"/>
             <a:r>
-              <a:rPr lang="en-US"/>
+              <a:rPr lang="en-US" smtClean="0"/>
               <a:t>Fifth level</a:t>
             </a:r>
+            <a:endParaRPr lang="en-US"/>
           </a:p>
         </p:txBody>
       </p:sp>
@@ -1348,7 +1344,7 @@
           <a:p>
             <a:fld id="{5BCAD085-E8A6-8845-BD4E-CB4CCA059FC4}" type="datetimeFigureOut">
               <a:rPr lang="en-US" smtClean="0"/>
-              <a:t>4/30/2026</a:t>
+              <a:t>1/27/13</a:t>
             </a:fld>
             <a:endParaRPr lang="en-US"/>
           </a:p>
@@ -1446,9 +1442,10 @@
           </a:lstStyle>
           <a:p>
             <a:r>
-              <a:rPr lang="en-US"/>
+              <a:rPr lang="en-US" smtClean="0"/>
               <a:t>Click to edit Master title style</a:t>
             </a:r>
+            <a:endParaRPr lang="en-US"/>
           </a:p>
         </p:txBody>
       </p:sp>
@@ -1511,7 +1508,7 @@
           <a:p>
             <a:pPr lvl="0"/>
             <a:r>
-              <a:rPr lang="en-US"/>
+              <a:rPr lang="en-US" smtClean="0"/>
               <a:t>Click to edit Master text styles</a:t>
             </a:r>
           </a:p>
@@ -1567,37 +1564,38 @@
           <a:p>
             <a:pPr lvl="0"/>
             <a:r>
-              <a:rPr lang="en-US"/>
+              <a:rPr lang="en-US" smtClean="0"/>
               <a:t>Click to edit Master text styles</a:t>
             </a:r>
           </a:p>
           <a:p>
             <a:pPr lvl="1"/>
             <a:r>
-              <a:rPr lang="en-US"/>
+              <a:rPr lang="en-US" smtClean="0"/>
               <a:t>Second level</a:t>
             </a:r>
           </a:p>
           <a:p>
             <a:pPr lvl="2"/>
             <a:r>
-              <a:rPr lang="en-US"/>
+              <a:rPr lang="en-US" smtClean="0"/>
               <a:t>Third level</a:t>
             </a:r>
           </a:p>
           <a:p>
             <a:pPr lvl="3"/>
             <a:r>
-              <a:rPr lang="en-US"/>
+              <a:rPr lang="en-US" smtClean="0"/>
               <a:t>Fourth level</a:t>
             </a:r>
           </a:p>
           <a:p>
             <a:pPr lvl="4"/>
             <a:r>
-              <a:rPr lang="en-US"/>
+              <a:rPr lang="en-US" smtClean="0"/>
               <a:t>Fifth level</a:t>
             </a:r>
+            <a:endParaRPr lang="en-US"/>
           </a:p>
         </p:txBody>
       </p:sp>
@@ -1660,7 +1658,7 @@
           <a:p>
             <a:pPr lvl="0"/>
             <a:r>
-              <a:rPr lang="en-US"/>
+              <a:rPr lang="en-US" smtClean="0"/>
               <a:t>Click to edit Master text styles</a:t>
             </a:r>
           </a:p>
@@ -1716,37 +1714,38 @@
           <a:p>
             <a:pPr lvl="0"/>
             <a:r>
-              <a:rPr lang="en-US"/>
+              <a:rPr lang="en-US" smtClean="0"/>
               <a:t>Click to edit Master text styles</a:t>
             </a:r>
           </a:p>
           <a:p>
             <a:pPr lvl="1"/>
             <a:r>
-              <a:rPr lang="en-US"/>
+              <a:rPr lang="en-US" smtClean="0"/>
               <a:t>Second level</a:t>
             </a:r>
           </a:p>
           <a:p>
             <a:pPr lvl="2"/>
             <a:r>
-              <a:rPr lang="en-US"/>
+              <a:rPr lang="en-US" smtClean="0"/>
               <a:t>Third level</a:t>
             </a:r>
           </a:p>
           <a:p>
             <a:pPr lvl="3"/>
             <a:r>
-              <a:rPr lang="en-US"/>
+              <a:rPr lang="en-US" smtClean="0"/>
               <a:t>Fourth level</a:t>
             </a:r>
           </a:p>
           <a:p>
             <a:pPr lvl="4"/>
             <a:r>
-              <a:rPr lang="en-US"/>
+              <a:rPr lang="en-US" smtClean="0"/>
               <a:t>Fifth level</a:t>
             </a:r>
+            <a:endParaRPr lang="en-US"/>
           </a:p>
         </p:txBody>
       </p:sp>
@@ -1767,7 +1766,7 @@
           <a:p>
             <a:fld id="{5BCAD085-E8A6-8845-BD4E-CB4CCA059FC4}" type="datetimeFigureOut">
               <a:rPr lang="en-US" smtClean="0"/>
-              <a:t>4/30/2026</a:t>
+              <a:t>1/27/13</a:t>
             </a:fld>
             <a:endParaRPr lang="en-US"/>
           </a:p>
@@ -1861,9 +1860,10 @@
           <a:lstStyle/>
           <a:p>
             <a:r>
-              <a:rPr lang="en-US"/>
+              <a:rPr lang="en-US" smtClean="0"/>
               <a:t>Click to edit Master title style</a:t>
             </a:r>
+            <a:endParaRPr lang="en-US"/>
           </a:p>
         </p:txBody>
       </p:sp>
@@ -1884,7 +1884,7 @@
           <a:p>
             <a:fld id="{5BCAD085-E8A6-8845-BD4E-CB4CCA059FC4}" type="datetimeFigureOut">
               <a:rPr lang="en-US" smtClean="0"/>
-              <a:t>4/30/2026</a:t>
+              <a:t>1/27/13</a:t>
             </a:fld>
             <a:endParaRPr lang="en-US"/>
           </a:p>
@@ -1979,7 +1979,7 @@
           <a:p>
             <a:fld id="{5BCAD085-E8A6-8845-BD4E-CB4CCA059FC4}" type="datetimeFigureOut">
               <a:rPr lang="en-US" smtClean="0"/>
-              <a:t>4/30/2026</a:t>
+              <a:t>1/27/13</a:t>
             </a:fld>
             <a:endParaRPr lang="en-US"/>
           </a:p>
@@ -2082,9 +2082,10 @@
           </a:lstStyle>
           <a:p>
             <a:r>
-              <a:rPr lang="en-US"/>
+              <a:rPr lang="en-US" smtClean="0"/>
               <a:t>Click to edit Master title style</a:t>
             </a:r>
+            <a:endParaRPr lang="en-US"/>
           </a:p>
         </p:txBody>
       </p:sp>
@@ -2138,37 +2139,38 @@
           <a:p>
             <a:pPr lvl="0"/>
             <a:r>
-              <a:rPr lang="en-US"/>
+              <a:rPr lang="en-US" smtClean="0"/>
               <a:t>Click to edit Master text styles</a:t>
             </a:r>
           </a:p>
           <a:p>
             <a:pPr lvl="1"/>
             <a:r>
-              <a:rPr lang="en-US"/>
+              <a:rPr lang="en-US" smtClean="0"/>
               <a:t>Second level</a:t>
             </a:r>
           </a:p>
           <a:p>
             <a:pPr lvl="2"/>
             <a:r>
-              <a:rPr lang="en-US"/>
+              <a:rPr lang="en-US" smtClean="0"/>
               <a:t>Third level</a:t>
             </a:r>
           </a:p>
           <a:p>
             <a:pPr lvl="3"/>
             <a:r>
-              <a:rPr lang="en-US"/>
+              <a:rPr lang="en-US" smtClean="0"/>
               <a:t>Fourth level</a:t>
             </a:r>
           </a:p>
           <a:p>
             <a:pPr lvl="4"/>
             <a:r>
-              <a:rPr lang="en-US"/>
+              <a:rPr lang="en-US" smtClean="0"/>
               <a:t>Fifth level</a:t>
             </a:r>
+            <a:endParaRPr lang="en-US"/>
           </a:p>
         </p:txBody>
       </p:sp>
@@ -2231,7 +2233,7 @@
           <a:p>
             <a:pPr lvl="0"/>
             <a:r>
-              <a:rPr lang="en-US"/>
+              <a:rPr lang="en-US" smtClean="0"/>
               <a:t>Click to edit Master text styles</a:t>
             </a:r>
           </a:p>
@@ -2254,7 +2256,7 @@
           <a:p>
             <a:fld id="{5BCAD085-E8A6-8845-BD4E-CB4CCA059FC4}" type="datetimeFigureOut">
               <a:rPr lang="en-US" smtClean="0"/>
-              <a:t>4/30/2026</a:t>
+              <a:t>1/27/13</a:t>
             </a:fld>
             <a:endParaRPr lang="en-US"/>
           </a:p>
@@ -2357,9 +2359,10 @@
           </a:lstStyle>
           <a:p>
             <a:r>
-              <a:rPr lang="en-US"/>
+              <a:rPr lang="en-US" smtClean="0"/>
               <a:t>Click to edit Master title style</a:t>
             </a:r>
+            <a:endParaRPr lang="en-US"/>
           </a:p>
         </p:txBody>
       </p:sp>
@@ -2483,7 +2486,7 @@
           <a:p>
             <a:pPr lvl="0"/>
             <a:r>
-              <a:rPr lang="en-US"/>
+              <a:rPr lang="en-US" smtClean="0"/>
               <a:t>Click to edit Master text styles</a:t>
             </a:r>
           </a:p>
@@ -2506,7 +2509,7 @@
           <a:p>
             <a:fld id="{5BCAD085-E8A6-8845-BD4E-CB4CCA059FC4}" type="datetimeFigureOut">
               <a:rPr lang="en-US" smtClean="0"/>
-              <a:t>4/30/2026</a:t>
+              <a:t>1/27/13</a:t>
             </a:fld>
             <a:endParaRPr lang="en-US"/>
           </a:p>
@@ -2615,9 +2618,10 @@
           <a:lstStyle/>
           <a:p>
             <a:r>
-              <a:rPr lang="en-US"/>
+              <a:rPr lang="en-US" smtClean="0"/>
               <a:t>Click to edit Master title style</a:t>
             </a:r>
+            <a:endParaRPr lang="en-US"/>
           </a:p>
         </p:txBody>
       </p:sp>
@@ -2648,37 +2652,38 @@
           <a:p>
             <a:pPr lvl="0"/>
             <a:r>
-              <a:rPr lang="en-US"/>
+              <a:rPr lang="en-US" smtClean="0"/>
               <a:t>Click to edit Master text styles</a:t>
             </a:r>
           </a:p>
           <a:p>
             <a:pPr lvl="1"/>
             <a:r>
-              <a:rPr lang="en-US"/>
+              <a:rPr lang="en-US" smtClean="0"/>
               <a:t>Second level</a:t>
             </a:r>
           </a:p>
           <a:p>
             <a:pPr lvl="2"/>
             <a:r>
-              <a:rPr lang="en-US"/>
+              <a:rPr lang="en-US" smtClean="0"/>
               <a:t>Third level</a:t>
             </a:r>
           </a:p>
           <a:p>
             <a:pPr lvl="3"/>
             <a:r>
-              <a:rPr lang="en-US"/>
+              <a:rPr lang="en-US" smtClean="0"/>
               <a:t>Fourth level</a:t>
             </a:r>
           </a:p>
           <a:p>
             <a:pPr lvl="4"/>
             <a:r>
-              <a:rPr lang="en-US"/>
+              <a:rPr lang="en-US" smtClean="0"/>
               <a:t>Fifth level</a:t>
             </a:r>
+            <a:endParaRPr lang="en-US"/>
           </a:p>
         </p:txBody>
       </p:sp>
@@ -2717,7 +2722,7 @@
           <a:p>
             <a:fld id="{5BCAD085-E8A6-8845-BD4E-CB4CCA059FC4}" type="datetimeFigureOut">
               <a:rPr lang="en-US" smtClean="0"/>
-              <a:t>4/30/2026</a:t>
+              <a:t>1/27/13</a:t>
             </a:fld>
             <a:endParaRPr lang="en-US"/>
           </a:p>
@@ -3100,7 +3105,7 @@
         </p:nvSpPr>
         <p:spPr>
           <a:xfrm>
-            <a:off x="0" y="0"/>
+            <a:off x="447675" y="447675"/>
             <a:ext cx="12192000" cy="6858000"/>
           </a:xfrm>
           <a:prstGeom prst="rect">
@@ -3116,187 +3121,14 @@
       </p:sp>
       <p:sp>
         <p:nvSpPr>
-          <p:cNvPr id="3" name="Freeform 3"/>
-          <p:cNvSpPr/>
-          <p:nvPr/>
-        </p:nvSpPr>
-        <p:spPr>
-          <a:xfrm>
-            <a:off x="447675" y="447675"/>
-            <a:ext cx="11296650" cy="5962650"/>
-          </a:xfrm>
-          <a:custGeom>
-            <a:avLst/>
-            <a:gdLst/>
-            <a:ahLst/>
-            <a:cxnLst/>
-            <a:rect l="l" t="t" r="r" b="b"/>
-            <a:pathLst>
-              <a:path w="11296650" h="5962650">
-                <a:moveTo>
-                  <a:pt x="0" y="0"/>
-                </a:moveTo>
-                <a:lnTo>
-                  <a:pt x="11296650" y="0"/>
-                </a:lnTo>
-                <a:lnTo>
-                  <a:pt x="11296650" y="5962650"/>
-                </a:lnTo>
-                <a:lnTo>
-                  <a:pt x="0" y="5962650"/>
-                </a:lnTo>
-                <a:close/>
-              </a:path>
-            </a:pathLst>
-          </a:custGeom>
-          <a:solidFill>
-            <a:srgbClr val="E9ECEF"/>
-          </a:solidFill>
-          <a:ln w="19050">
-            <a:solidFill>
-              <a:srgbClr val="DEE2E6"/>
-            </a:solidFill>
-          </a:ln>
-        </p:spPr>
-      </p:sp>
-      <p:sp>
-        <p:nvSpPr>
-          <p:cNvPr id="4" name="Ellipse 4"/>
-          <p:cNvSpPr/>
-          <p:nvPr/>
-        </p:nvSpPr>
-        <p:spPr>
-          <a:xfrm>
-            <a:off x="4953000" y="2286000"/>
-            <a:ext cx="2286000" cy="2286000"/>
-          </a:xfrm>
-          <a:prstGeom prst="ellipse">
-            <a:avLst/>
-          </a:prstGeom>
-          <a:solidFill>
-            <a:srgbClr val="0066CC">
-              <a:alpha val="80000"/>
-            </a:srgbClr>
-          </a:solidFill>
-          <a:ln>
-            <a:noFill/>
-          </a:ln>
-        </p:spPr>
-      </p:sp>
-      <p:sp>
-        <p:nvSpPr>
-          <p:cNvPr id="5" name="Freeform 5"/>
-          <p:cNvSpPr/>
-          <p:nvPr/>
-        </p:nvSpPr>
-        <p:spPr>
-          <a:xfrm>
-            <a:off x="3619500" y="952500"/>
-            <a:ext cx="4953000" cy="4953000"/>
-          </a:xfrm>
-          <a:custGeom>
-            <a:avLst/>
-            <a:gdLst/>
-            <a:ahLst/>
-            <a:cxnLst/>
-            <a:rect l="l" t="t" r="r" b="b"/>
-            <a:pathLst>
-              <a:path w="4953000" h="4953000">
-                <a:moveTo>
-                  <a:pt x="2476500" y="0"/>
-                </a:moveTo>
-                <a:cubicBezTo>
-                  <a:pt x="1108767" y="0"/>
-                  <a:pt x="0" y="1108767"/>
-                  <a:pt x="0" y="2476500"/>
-                </a:cubicBezTo>
-                <a:cubicBezTo>
-                  <a:pt x="0" y="3844233"/>
-                  <a:pt x="1108767" y="4953000"/>
-                  <a:pt x="2476500" y="4953000"/>
-                </a:cubicBezTo>
-                <a:cubicBezTo>
-                  <a:pt x="3844233" y="4953000"/>
-                  <a:pt x="4953000" y="3844233"/>
-                  <a:pt x="4953000" y="2476500"/>
-                </a:cubicBezTo>
-                <a:cubicBezTo>
-                  <a:pt x="4953000" y="1108767"/>
-                  <a:pt x="3844233" y="0"/>
-                  <a:pt x="2476500" y="0"/>
-                </a:cubicBezTo>
-                <a:close/>
-                <a:moveTo>
-                  <a:pt x="2476500" y="1333500"/>
-                </a:moveTo>
-                <a:cubicBezTo>
-                  <a:pt x="3107761" y="1333500"/>
-                  <a:pt x="3619500" y="1845239"/>
-                  <a:pt x="3619500" y="2476500"/>
-                </a:cubicBezTo>
-                <a:cubicBezTo>
-                  <a:pt x="3619500" y="3107761"/>
-                  <a:pt x="3107761" y="3619500"/>
-                  <a:pt x="2476500" y="3619500"/>
-                </a:cubicBezTo>
-                <a:cubicBezTo>
-                  <a:pt x="1845239" y="3619500"/>
-                  <a:pt x="1333500" y="3107761"/>
-                  <a:pt x="1333500" y="2476500"/>
-                </a:cubicBezTo>
-                <a:cubicBezTo>
-                  <a:pt x="1333500" y="1845239"/>
-                  <a:pt x="1845239" y="1333500"/>
-                  <a:pt x="2476500" y="1333500"/>
-                </a:cubicBezTo>
-                <a:close/>
-              </a:path>
-            </a:pathLst>
-          </a:custGeom>
-          <a:solidFill>
-            <a:srgbClr val="FF4D4D">
-              <a:alpha val="30000"/>
-            </a:srgbClr>
-          </a:solidFill>
-          <a:ln>
-            <a:noFill/>
-          </a:ln>
-        </p:spPr>
-      </p:sp>
-      <p:sp>
-        <p:nvSpPr>
-          <p:cNvPr id="6" name="Rectangle 6"/>
-          <p:cNvSpPr/>
-          <p:nvPr/>
-        </p:nvSpPr>
-        <p:spPr>
-          <a:xfrm>
-            <a:off x="762000" y="762000"/>
-            <a:ext cx="3429000" cy="2667000"/>
-          </a:xfrm>
-          <a:prstGeom prst="rect">
-            <a:avLst/>
-          </a:prstGeom>
-          <a:solidFill>
-            <a:srgbClr val="F8F9FA"/>
-          </a:solidFill>
-          <a:ln w="9525">
-            <a:solidFill>
-              <a:srgbClr val="E9ECEF"/>
-            </a:solidFill>
-          </a:ln>
-        </p:spPr>
-      </p:sp>
-      <p:sp>
-        <p:nvSpPr>
-          <p:cNvPr id="7" name="TextBox 7"/>
+          <p:cNvPr id="3" name="TextBox 3"/>
           <p:cNvSpPr txBox="1"/>
           <p:nvPr/>
         </p:nvSpPr>
         <p:spPr>
           <a:xfrm>
-            <a:off x="967740" y="996315"/>
-            <a:ext cx="2488625" cy="365760"/>
+            <a:off x="434340" y="643890"/>
+            <a:ext cx="5911453" cy="365760"/>
           </a:xfrm>
           <a:prstGeom prst="rect">
             <a:avLst/>
@@ -3322,21 +3154,43 @@
                 <a:ea typeface="Microsoft YaHei"/>
                 <a:cs typeface="Google Sans"/>
               </a:rPr>
-              <a:t>85,000+ RESIDENTS</a:t>
-            </a:r>
-          </a:p>
-        </p:txBody>
-      </p:sp>
-      <p:sp>
-        <p:nvSpPr>
-          <p:cNvPr id="8" name="TextBox 8"/>
+              <a:t>КРИТИЧЕСКИЙ ДЕФИЦИТ ТРАНСПОРТНОГО ОХВАТА</a:t>
+            </a:r>
+          </a:p>
+        </p:txBody>
+      </p:sp>
+      <p:sp>
+        <p:nvSpPr>
+          <p:cNvPr id="4" name="Rectangle 4"/>
+          <p:cNvSpPr/>
+          <p:nvPr/>
+        </p:nvSpPr>
+        <p:spPr>
+          <a:xfrm>
+            <a:off x="457200" y="1143000"/>
+            <a:ext cx="3352800" cy="1447800"/>
+          </a:xfrm>
+          <a:prstGeom prst="rect">
+            <a:avLst/>
+          </a:prstGeom>
+          <a:solidFill>
+            <a:srgbClr val="F8F9FA"/>
+          </a:solidFill>
+          <a:ln>
+            <a:noFill/>
+          </a:ln>
+        </p:spPr>
+      </p:sp>
+      <p:sp>
+        <p:nvSpPr>
+          <p:cNvPr id="5" name="TextBox 5"/>
           <p:cNvSpPr txBox="1"/>
           <p:nvPr/>
         </p:nvSpPr>
         <p:spPr>
           <a:xfrm>
-            <a:off x="967740" y="1282065"/>
-            <a:ext cx="2709453" cy="365760"/>
+            <a:off x="643890" y="1320165"/>
+            <a:ext cx="1905648" cy="670560"/>
           </a:xfrm>
           <a:prstGeom prst="rect">
             <a:avLst/>
@@ -3354,7 +3208,7 @@
           <a:p>
             <a:pPr algn="l"/>
             <a:r>
-              <a:rPr lang="zh-CN" sz="1800" b="1" dirty="0">
+              <a:rPr lang="zh-CN" sz="3300" b="1" dirty="0">
                 <a:solidFill>
                   <a:srgbClr val="0066CC"/>
                 </a:solidFill>
@@ -3362,43 +3216,21 @@
                 <a:ea typeface="Microsoft YaHei"/>
                 <a:cs typeface="Google Sans"/>
               </a:rPr>
-              <a:t>CURRENTLY UNSERVED</a:t>
-            </a:r>
-          </a:p>
-        </p:txBody>
-      </p:sp>
-      <p:sp>
-        <p:nvSpPr>
-          <p:cNvPr id="9" name="Rectangle 9"/>
-          <p:cNvSpPr/>
-          <p:nvPr/>
-        </p:nvSpPr>
-        <p:spPr>
-          <a:xfrm>
-            <a:off x="990600" y="1762125"/>
-            <a:ext cx="2971800" cy="9525"/>
-          </a:xfrm>
-          <a:prstGeom prst="rect">
-            <a:avLst/>
-          </a:prstGeom>
-          <a:solidFill>
-            <a:srgbClr val="DEE2E6"/>
-          </a:solidFill>
-          <a:ln>
-            <a:noFill/>
-          </a:ln>
-        </p:spPr>
-      </p:sp>
-      <p:sp>
-        <p:nvSpPr>
-          <p:cNvPr id="10" name="TextBox 10"/>
+              <a:t>85 000+</a:t>
+            </a:r>
+          </a:p>
+        </p:txBody>
+      </p:sp>
+      <p:sp>
+        <p:nvSpPr>
+          <p:cNvPr id="6" name="TextBox 6"/>
           <p:cNvSpPr txBox="1"/>
           <p:nvPr/>
         </p:nvSpPr>
         <p:spPr>
           <a:xfrm>
-            <a:off x="977265" y="1982152"/>
-            <a:ext cx="2264850" cy="213360"/>
+            <a:off x="672465" y="1867852"/>
+            <a:ext cx="2876726" cy="213360"/>
           </a:xfrm>
           <a:prstGeom prst="rect">
             <a:avLst/>
@@ -3424,21 +3256,21 @@
                 <a:ea typeface="Microsoft YaHei"/>
                 <a:cs typeface="Google Sans"/>
               </a:rPr>
-              <a:t>High density of disconnected</a:t>
-            </a:r>
-          </a:p>
-        </p:txBody>
-      </p:sp>
-      <p:sp>
-        <p:nvSpPr>
-          <p:cNvPr id="11" name="TextBox 11"/>
+              <a:t>жителей пригорода не имеют доступа</a:t>
+            </a:r>
+          </a:p>
+        </p:txBody>
+      </p:sp>
+      <p:sp>
+        <p:nvSpPr>
+          <p:cNvPr id="7" name="TextBox 7"/>
           <p:cNvSpPr txBox="1"/>
           <p:nvPr/>
         </p:nvSpPr>
         <p:spPr>
           <a:xfrm>
-            <a:off x="977265" y="2153602"/>
-            <a:ext cx="1749585" cy="213360"/>
+            <a:off x="672465" y="2096452"/>
+            <a:ext cx="2248748" cy="213360"/>
           </a:xfrm>
           <a:prstGeom prst="rect">
             <a:avLst/>
@@ -3464,21 +3296,43 @@
                 <a:ea typeface="Microsoft YaHei"/>
                 <a:cs typeface="Google Sans"/>
               </a:rPr>
-              <a:t>suburban settlements</a:t>
-            </a:r>
-          </a:p>
-        </p:txBody>
-      </p:sp>
-      <p:sp>
-        <p:nvSpPr>
-          <p:cNvPr id="12" name="TextBox 12"/>
+              <a:t>к общественному транспорту</a:t>
+            </a:r>
+          </a:p>
+        </p:txBody>
+      </p:sp>
+      <p:sp>
+        <p:nvSpPr>
+          <p:cNvPr id="8" name="Rectangle 8"/>
+          <p:cNvSpPr/>
+          <p:nvPr/>
+        </p:nvSpPr>
+        <p:spPr>
+          <a:xfrm>
+            <a:off x="457200" y="2743200"/>
+            <a:ext cx="3352800" cy="762000"/>
+          </a:xfrm>
+          <a:prstGeom prst="rect">
+            <a:avLst/>
+          </a:prstGeom>
+          <a:solidFill>
+            <a:srgbClr val="F8F9FA"/>
+          </a:solidFill>
+          <a:ln>
+            <a:noFill/>
+          </a:ln>
+        </p:spPr>
+      </p:sp>
+      <p:sp>
+        <p:nvSpPr>
+          <p:cNvPr id="9" name="TextBox 9"/>
           <p:cNvSpPr txBox="1"/>
           <p:nvPr/>
         </p:nvSpPr>
         <p:spPr>
           <a:xfrm>
-            <a:off x="977265" y="2506028"/>
-            <a:ext cx="1612718" cy="213360"/>
+            <a:off x="672465" y="2934652"/>
+            <a:ext cx="2699604" cy="213360"/>
           </a:xfrm>
           <a:prstGeom prst="rect">
             <a:avLst/>
@@ -3504,21 +3358,21 @@
                 <a:ea typeface="Microsoft YaHei"/>
                 <a:cs typeface="Google Sans"/>
               </a:rPr>
-              <a:t>Critical gap in public</a:t>
-            </a:r>
-          </a:p>
-        </p:txBody>
-      </p:sp>
-      <p:sp>
-        <p:nvSpPr>
-          <p:cNvPr id="13" name="TextBox 13"/>
+              <a:t>Интеграция 16 населенных пунктов</a:t>
+            </a:r>
+          </a:p>
+        </p:txBody>
+      </p:sp>
+      <p:sp>
+        <p:nvSpPr>
+          <p:cNvPr id="10" name="TextBox 10"/>
           <p:cNvSpPr txBox="1"/>
           <p:nvPr/>
         </p:nvSpPr>
         <p:spPr>
           <a:xfrm>
-            <a:off x="977265" y="2677478"/>
-            <a:ext cx="1363137" cy="213360"/>
+            <a:off x="674370" y="3103245"/>
+            <a:ext cx="2421731" cy="182880"/>
           </a:xfrm>
           <a:prstGeom prst="rect">
             <a:avLst/>
@@ -3536,7 +3390,233 @@
           <a:p>
             <a:pPr algn="l"/>
             <a:r>
-              <a:rPr lang="zh-CN" sz="1050" b="1" dirty="0">
+              <a:rPr lang="zh-CN" sz="900" dirty="0">
+                <a:solidFill>
+                  <a:srgbClr val="808080"/>
+                </a:solidFill>
+                <a:latin typeface="Google Sans"/>
+                <a:ea typeface="Microsoft YaHei"/>
+                <a:cs typeface="Google Sans"/>
+              </a:rPr>
+              <a:t>Необходима интеграция в единую сеть</a:t>
+            </a:r>
+          </a:p>
+        </p:txBody>
+      </p:sp>
+      <p:sp>
+        <p:nvSpPr>
+          <p:cNvPr id="11" name="Rectangle 11"/>
+          <p:cNvSpPr/>
+          <p:nvPr/>
+        </p:nvSpPr>
+        <p:spPr>
+          <a:xfrm>
+            <a:off x="4191000" y="1143000"/>
+            <a:ext cx="7543800" cy="4724400"/>
+          </a:xfrm>
+          <a:prstGeom prst="rect">
+            <a:avLst/>
+          </a:prstGeom>
+          <a:solidFill>
+            <a:srgbClr val="F8F9FA"/>
+          </a:solidFill>
+          <a:ln>
+            <a:noFill/>
+          </a:ln>
+        </p:spPr>
+      </p:sp>
+      <p:sp>
+        <p:nvSpPr>
+          <p:cNvPr id="12" name="Freeform 12"/>
+          <p:cNvSpPr/>
+          <p:nvPr/>
+        </p:nvSpPr>
+        <p:spPr>
+          <a:xfrm>
+            <a:off x="4762500" y="1587500"/>
+            <a:ext cx="5715000" cy="2222500"/>
+          </a:xfrm>
+          <a:custGeom>
+            <a:avLst/>
+            <a:gdLst/>
+            <a:ahLst/>
+            <a:cxnLst/>
+            <a:rect l="l" t="t" r="r" b="b"/>
+            <a:pathLst>
+              <a:path w="5715000" h="2222500">
+                <a:moveTo>
+                  <a:pt x="0" y="317500"/>
+                </a:moveTo>
+                <a:cubicBezTo>
+                  <a:pt x="635000" y="0"/>
+                  <a:pt x="1270000" y="158750"/>
+                  <a:pt x="1905000" y="793750"/>
+                </a:cubicBezTo>
+                <a:cubicBezTo>
+                  <a:pt x="2540000" y="1428750"/>
+                  <a:pt x="3175000" y="1587500"/>
+                  <a:pt x="3810000" y="1270000"/>
+                </a:cubicBezTo>
+                <a:cubicBezTo>
+                  <a:pt x="4445000" y="952500"/>
+                  <a:pt x="5080000" y="1270000"/>
+                  <a:pt x="5715000" y="2222500"/>
+                </a:cubicBezTo>
+              </a:path>
+            </a:pathLst>
+          </a:custGeom>
+          <a:noFill/>
+          <a:ln w="19050">
+            <a:solidFill>
+              <a:srgbClr val="CCCCCC"/>
+            </a:solidFill>
+          </a:ln>
+        </p:spPr>
+      </p:sp>
+      <p:sp>
+        <p:nvSpPr>
+          <p:cNvPr id="13" name="Ellipse 13"/>
+          <p:cNvSpPr/>
+          <p:nvPr/>
+        </p:nvSpPr>
+        <p:spPr>
+          <a:xfrm>
+            <a:off x="5429250" y="2095500"/>
+            <a:ext cx="1524000" cy="1524000"/>
+          </a:xfrm>
+          <a:prstGeom prst="ellipse">
+            <a:avLst/>
+          </a:prstGeom>
+          <a:solidFill>
+            <a:srgbClr val="28A745">
+              <a:alpha val="60000"/>
+            </a:srgbClr>
+          </a:solidFill>
+          <a:ln>
+            <a:noFill/>
+          </a:ln>
+        </p:spPr>
+      </p:sp>
+      <p:sp>
+        <p:nvSpPr>
+          <p:cNvPr id="14" name="Ellipse 14"/>
+          <p:cNvSpPr/>
+          <p:nvPr/>
+        </p:nvSpPr>
+        <p:spPr>
+          <a:xfrm>
+            <a:off x="7429500" y="2667000"/>
+            <a:ext cx="2286000" cy="2286000"/>
+          </a:xfrm>
+          <a:prstGeom prst="ellipse">
+            <a:avLst/>
+          </a:prstGeom>
+          <a:solidFill>
+            <a:srgbClr val="DC3545">
+              <a:alpha val="60000"/>
+            </a:srgbClr>
+          </a:solidFill>
+          <a:ln>
+            <a:noFill/>
+          </a:ln>
+        </p:spPr>
+      </p:sp>
+      <p:sp>
+        <p:nvSpPr>
+          <p:cNvPr id="15" name="Ellipse 15"/>
+          <p:cNvSpPr/>
+          <p:nvPr/>
+        </p:nvSpPr>
+        <p:spPr>
+          <a:xfrm>
+            <a:off x="7620000" y="1905000"/>
+            <a:ext cx="952500" cy="952500"/>
+          </a:xfrm>
+          <a:prstGeom prst="ellipse">
+            <a:avLst/>
+          </a:prstGeom>
+          <a:solidFill>
+            <a:srgbClr val="DC3545">
+              <a:alpha val="60000"/>
+            </a:srgbClr>
+          </a:solidFill>
+          <a:ln>
+            <a:noFill/>
+          </a:ln>
+        </p:spPr>
+      </p:sp>
+      <p:sp>
+        <p:nvSpPr>
+          <p:cNvPr id="16" name="Rectangle 16"/>
+          <p:cNvSpPr/>
+          <p:nvPr/>
+        </p:nvSpPr>
+        <p:spPr>
+          <a:xfrm>
+            <a:off x="4381500" y="5334000"/>
+            <a:ext cx="1905000" cy="381000"/>
+          </a:xfrm>
+          <a:prstGeom prst="rect">
+            <a:avLst/>
+          </a:prstGeom>
+          <a:solidFill>
+            <a:srgbClr val="FFFFFF"/>
+          </a:solidFill>
+          <a:ln>
+            <a:noFill/>
+          </a:ln>
+        </p:spPr>
+      </p:sp>
+      <p:sp>
+        <p:nvSpPr>
+          <p:cNvPr id="17" name="Ellipse 17"/>
+          <p:cNvSpPr/>
+          <p:nvPr/>
+        </p:nvSpPr>
+        <p:spPr>
+          <a:xfrm>
+            <a:off x="4495800" y="5448300"/>
+            <a:ext cx="152400" cy="152400"/>
+          </a:xfrm>
+          <a:prstGeom prst="ellipse">
+            <a:avLst/>
+          </a:prstGeom>
+          <a:solidFill>
+            <a:srgbClr val="28A745"/>
+          </a:solidFill>
+          <a:ln>
+            <a:noFill/>
+          </a:ln>
+        </p:spPr>
+      </p:sp>
+      <p:sp>
+        <p:nvSpPr>
+          <p:cNvPr id="18" name="TextBox 18"/>
+          <p:cNvSpPr txBox="1"/>
+          <p:nvPr/>
+        </p:nvSpPr>
+        <p:spPr>
+          <a:xfrm>
+            <a:off x="4714875" y="5481638"/>
+            <a:ext cx="501015" cy="152400"/>
+          </a:xfrm>
+          <a:prstGeom prst="rect">
+            <a:avLst/>
+          </a:prstGeom>
+          <a:noFill/>
+          <a:ln>
+            <a:noFill/>
+          </a:ln>
+        </p:spPr>
+        <p:txBody>
+          <a:bodyPr wrap="none" lIns="0" tIns="0" rIns="0" bIns="0" anchor="t" anchorCtr="0">
+            <a:spAutoFit/>
+          </a:bodyPr>
+          <a:lstStyle/>
+          <a:p>
+            <a:pPr algn="l"/>
+            <a:r>
+              <a:rPr lang="zh-CN" sz="750" dirty="0">
                 <a:solidFill>
                   <a:srgbClr val="1A1A1A"/>
                 </a:solidFill>
@@ -3544,51 +3624,27 @@
                 <a:ea typeface="Microsoft YaHei"/>
                 <a:cs typeface="Google Sans"/>
               </a:rPr>
-              <a:t>transit coverage</a:t>
-            </a:r>
-          </a:p>
-        </p:txBody>
-      </p:sp>
-      <p:sp>
-        <p:nvSpPr>
-          <p:cNvPr id="14" name="Rectangle 14"/>
+              <a:t>Охвачено</a:t>
+            </a:r>
+          </a:p>
+        </p:txBody>
+      </p:sp>
+      <p:sp>
+        <p:nvSpPr>
+          <p:cNvPr id="19" name="Ellipse 19"/>
           <p:cNvSpPr/>
           <p:nvPr/>
         </p:nvSpPr>
         <p:spPr>
           <a:xfrm>
-            <a:off x="762000" y="5524500"/>
-            <a:ext cx="2095500" cy="857250"/>
-          </a:xfrm>
-          <a:prstGeom prst="rect">
+            <a:off x="5257800" y="5448300"/>
+            <a:ext cx="152400" cy="152400"/>
+          </a:xfrm>
+          <a:prstGeom prst="ellipse">
             <a:avLst/>
           </a:prstGeom>
           <a:solidFill>
-            <a:srgbClr val="F8F9FA"/>
-          </a:solidFill>
-          <a:ln w="9525">
-            <a:solidFill>
-              <a:srgbClr val="E9ECEF"/>
-            </a:solidFill>
-          </a:ln>
-        </p:spPr>
-      </p:sp>
-      <p:sp>
-        <p:nvSpPr>
-          <p:cNvPr id="15" name="Ellipse 15"/>
-          <p:cNvSpPr/>
-          <p:nvPr/>
-        </p:nvSpPr>
-        <p:spPr>
-          <a:xfrm>
-            <a:off x="923925" y="5686425"/>
-            <a:ext cx="152400" cy="152400"/>
-          </a:xfrm>
-          <a:prstGeom prst="ellipse">
-            <a:avLst/>
-          </a:prstGeom>
-          <a:solidFill>
-            <a:srgbClr val="0066CC"/>
+            <a:srgbClr val="DC3545"/>
           </a:solidFill>
           <a:ln>
             <a:noFill/>
@@ -3597,14 +3653,14 @@
       </p:sp>
       <p:sp>
         <p:nvSpPr>
-          <p:cNvPr id="16" name="TextBox 16"/>
+          <p:cNvPr id="20" name="TextBox 20"/>
           <p:cNvSpPr txBox="1"/>
           <p:nvPr/>
         </p:nvSpPr>
         <p:spPr>
           <a:xfrm>
-            <a:off x="1179195" y="5713095"/>
-            <a:ext cx="785241" cy="182880"/>
+            <a:off x="5476875" y="5481638"/>
+            <a:ext cx="440769" cy="152400"/>
           </a:xfrm>
           <a:prstGeom prst="rect">
             <a:avLst/>
@@ -3622,7 +3678,7 @@
           <a:p>
             <a:pPr algn="l"/>
             <a:r>
-              <a:rPr lang="zh-CN" sz="900" dirty="0">
+              <a:rPr lang="zh-CN" sz="750" dirty="0">
                 <a:solidFill>
                   <a:srgbClr val="1A1A1A"/>
                 </a:solidFill>
@@ -3630,45 +3686,21 @@
                 <a:ea typeface="Microsoft YaHei"/>
                 <a:cs typeface="Google Sans"/>
               </a:rPr>
-              <a:t>Served Area</a:t>
-            </a:r>
-          </a:p>
-        </p:txBody>
-      </p:sp>
-      <p:sp>
-        <p:nvSpPr>
-          <p:cNvPr id="17" name="Ellipse 17"/>
-          <p:cNvSpPr/>
-          <p:nvPr/>
-        </p:nvSpPr>
-        <p:spPr>
-          <a:xfrm>
-            <a:off x="923925" y="5972175"/>
-            <a:ext cx="152400" cy="152400"/>
-          </a:xfrm>
-          <a:prstGeom prst="ellipse">
-            <a:avLst/>
-          </a:prstGeom>
-          <a:solidFill>
-            <a:srgbClr val="FF4D4D">
-              <a:alpha val="50000"/>
-            </a:srgbClr>
-          </a:solidFill>
-          <a:ln>
-            <a:noFill/>
-          </a:ln>
-        </p:spPr>
-      </p:sp>
-      <p:sp>
-        <p:nvSpPr>
-          <p:cNvPr id="18" name="TextBox 18"/>
+              <a:t>Дефицит</a:t>
+            </a:r>
+          </a:p>
+        </p:txBody>
+      </p:sp>
+      <p:sp>
+        <p:nvSpPr>
+          <p:cNvPr id="21" name="TextBox 21"/>
           <p:cNvSpPr txBox="1"/>
           <p:nvPr/>
         </p:nvSpPr>
         <p:spPr>
           <a:xfrm>
-            <a:off x="1179195" y="5998845"/>
-            <a:ext cx="1258443" cy="182880"/>
+            <a:off x="447675" y="6329362"/>
+            <a:ext cx="3891201" cy="152400"/>
           </a:xfrm>
           <a:prstGeom prst="rect">
             <a:avLst/>
@@ -3686,15 +3718,15 @@
           <a:p>
             <a:pPr algn="l"/>
             <a:r>
-              <a:rPr lang="zh-CN" sz="900" dirty="0">
+              <a:rPr lang="zh-CN" sz="750" dirty="0">
                 <a:solidFill>
-                  <a:srgbClr val="1A1A1A"/>
+                  <a:srgbClr val="808080"/>
                 </a:solidFill>
                 <a:latin typeface="Google Sans"/>
                 <a:ea typeface="Microsoft YaHei"/>
                 <a:cs typeface="Google Sans"/>
               </a:rPr>
-              <a:t>Unserved Periphery</a:t>
+              <a:t>Визуализация плотности населения и транспортной доступности региона</a:t>
             </a:r>
           </a:p>
         </p:txBody>
@@ -3732,7 +3764,7 @@
         </p:nvSpPr>
         <p:spPr>
           <a:xfrm>
-            <a:off x="0" y="0"/>
+            <a:off x="447675" y="447675"/>
             <a:ext cx="12192000" cy="6858000"/>
           </a:xfrm>
           <a:prstGeom prst="rect">
@@ -3754,8 +3786,8 @@
         </p:nvSpPr>
         <p:spPr>
           <a:xfrm>
-            <a:off x="424815" y="615315"/>
-            <a:ext cx="5428393" cy="365760"/>
+            <a:off x="434340" y="643890"/>
+            <a:ext cx="5538807" cy="365760"/>
           </a:xfrm>
           <a:prstGeom prst="rect">
             <a:avLst/>
@@ -3781,7 +3813,7 @@
                 <a:ea typeface="Microsoft YaHei"/>
                 <a:cs typeface="Google Sans"/>
               </a:rPr>
-              <a:t>BUILDING A CONTINUOUS TRANSIT BACKBONE</a:t>
+              <a:t>СОЗДАНИЕ НЕПРЕРЫВНОГО КАРКАСА BUS LANE</a:t>
             </a:r>
           </a:p>
         </p:txBody>
@@ -3794,8 +3826,8 @@
         </p:nvSpPr>
         <p:spPr>
           <a:xfrm>
-            <a:off x="447675" y="1143000"/>
-            <a:ext cx="6191250" cy="5267325"/>
+            <a:off x="457200" y="1143000"/>
+            <a:ext cx="6172200" cy="5257800"/>
           </a:xfrm>
           <a:prstGeom prst="rect">
             <a:avLst/>
@@ -3808,181 +3840,70 @@
           </a:ln>
         </p:spPr>
       </p:sp>
-      <p:grpSp>
-        <p:nvGrpSpPr>
-          <p:cNvPr id="9" name="Group 9"/>
-          <p:cNvGrpSpPr/>
-          <p:nvPr/>
-        </p:nvGrpSpPr>
-        <p:grpSpPr>
-          <a:xfrm>
-            <a:off x="1428750" y="1428750"/>
-            <a:ext cx="4286250" cy="3810000"/>
-            <a:chOff x="1428750" y="1428750"/>
-            <a:chExt cx="4286250" cy="3810000"/>
-          </a:xfrm>
-        </p:grpSpPr>
-        <p:sp>
-          <p:nvSpPr>
-            <p:cNvPr id="5" name="Freeform 5"/>
-            <p:cNvSpPr/>
-            <p:nvPr/>
-          </p:nvSpPr>
-          <p:spPr>
-            <a:xfrm>
-              <a:off x="1428750" y="2381250"/>
-              <a:ext cx="4286250" cy="1428750"/>
-            </a:xfrm>
-            <a:custGeom>
-              <a:avLst/>
-              <a:gdLst/>
-              <a:ahLst/>
-              <a:cxnLst/>
-              <a:rect l="l" t="t" r="r" b="b"/>
-              <a:pathLst>
-                <a:path w="4286250" h="1428750">
-                  <a:moveTo>
-                    <a:pt x="0" y="0"/>
-                  </a:moveTo>
-                  <a:lnTo>
-                    <a:pt x="1905000" y="0"/>
-                  </a:lnTo>
-                  <a:lnTo>
-                    <a:pt x="2857500" y="1428750"/>
-                  </a:lnTo>
-                  <a:lnTo>
-                    <a:pt x="4286250" y="1428750"/>
-                  </a:lnTo>
-                </a:path>
-              </a:pathLst>
-            </a:custGeom>
-            <a:noFill/>
-            <a:ln w="38100" cap="rnd">
-              <a:solidFill>
-                <a:srgbClr val="D1D1D1"/>
-              </a:solidFill>
-            </a:ln>
-          </p:spPr>
-        </p:sp>
-        <p:sp>
-          <p:nvSpPr>
-            <p:cNvPr id="6" name="Freeform 6"/>
-            <p:cNvSpPr/>
-            <p:nvPr/>
-          </p:nvSpPr>
-          <p:spPr>
-            <a:xfrm>
-              <a:off x="2381250" y="1428750"/>
-              <a:ext cx="9525" cy="3810000"/>
-            </a:xfrm>
-            <a:custGeom>
-              <a:avLst/>
-              <a:gdLst/>
-              <a:ahLst/>
-              <a:cxnLst/>
-              <a:rect l="l" t="t" r="r" b="b"/>
-              <a:pathLst>
-                <a:path w="9525" h="3810000">
-                  <a:moveTo>
-                    <a:pt x="0" y="0"/>
-                  </a:moveTo>
-                  <a:lnTo>
-                    <a:pt x="0" y="3810000"/>
-                  </a:lnTo>
-                </a:path>
-              </a:pathLst>
-            </a:custGeom>
-            <a:noFill/>
-            <a:ln w="38100" cap="rnd">
-              <a:solidFill>
-                <a:srgbClr val="D1D1D1"/>
-              </a:solidFill>
-            </a:ln>
-          </p:spPr>
-        </p:sp>
-        <p:sp>
-          <p:nvSpPr>
-            <p:cNvPr id="7" name="Freeform 7"/>
-            <p:cNvSpPr/>
-            <p:nvPr/>
-          </p:nvSpPr>
-          <p:spPr>
-            <a:xfrm>
-              <a:off x="4286250" y="3810000"/>
-              <a:ext cx="952500" cy="1428750"/>
-            </a:xfrm>
-            <a:custGeom>
-              <a:avLst/>
-              <a:gdLst/>
-              <a:ahLst/>
-              <a:cxnLst/>
-              <a:rect l="l" t="t" r="r" b="b"/>
-              <a:pathLst>
-                <a:path w="952500" h="1428750">
-                  <a:moveTo>
-                    <a:pt x="0" y="0"/>
-                  </a:moveTo>
-                  <a:lnTo>
-                    <a:pt x="952500" y="1428750"/>
-                  </a:lnTo>
-                </a:path>
-              </a:pathLst>
-            </a:custGeom>
-            <a:noFill/>
-            <a:ln w="38100" cap="rnd">
-              <a:solidFill>
-                <a:srgbClr val="0066CC"/>
-              </a:solidFill>
-            </a:ln>
-          </p:spPr>
-        </p:sp>
-        <p:sp>
-          <p:nvSpPr>
-            <p:cNvPr id="8" name="Freeform 8"/>
-            <p:cNvSpPr/>
-            <p:nvPr/>
-          </p:nvSpPr>
-          <p:spPr>
-            <a:xfrm>
-              <a:off x="3333750" y="2381250"/>
-              <a:ext cx="1428750" cy="9525"/>
-            </a:xfrm>
-            <a:custGeom>
-              <a:avLst/>
-              <a:gdLst/>
-              <a:ahLst/>
-              <a:cxnLst/>
-              <a:rect l="l" t="t" r="r" b="b"/>
-              <a:pathLst>
-                <a:path w="1428750" h="9525">
-                  <a:moveTo>
-                    <a:pt x="0" y="0"/>
-                  </a:moveTo>
-                  <a:lnTo>
-                    <a:pt x="1428750" y="0"/>
-                  </a:lnTo>
-                </a:path>
-              </a:pathLst>
-            </a:custGeom>
-            <a:noFill/>
-            <a:ln w="38100" cap="rnd">
-              <a:solidFill>
-                <a:srgbClr val="0066CC"/>
-              </a:solidFill>
-            </a:ln>
-          </p:spPr>
-        </p:sp>
-      </p:grpSp>
-      <p:sp>
-        <p:nvSpPr>
-          <p:cNvPr id="10" name="Ellipse 10"/>
+      <p:sp>
+        <p:nvSpPr>
+          <p:cNvPr id="5" name="Freeform 5"/>
           <p:cNvSpPr/>
           <p:nvPr/>
         </p:nvSpPr>
         <p:spPr>
           <a:xfrm>
-            <a:off x="2305050" y="2305050"/>
-            <a:ext cx="152400" cy="152400"/>
+            <a:off x="1428750" y="1905000"/>
+            <a:ext cx="4286250" cy="3333750"/>
+          </a:xfrm>
+          <a:custGeom>
+            <a:avLst/>
+            <a:gdLst/>
+            <a:ahLst/>
+            <a:cxnLst/>
+            <a:rect l="l" t="t" r="r" b="b"/>
+            <a:pathLst>
+              <a:path w="4286250" h="3333750">
+                <a:moveTo>
+                  <a:pt x="0" y="0"/>
+                </a:moveTo>
+                <a:lnTo>
+                  <a:pt x="1428750" y="476250"/>
+                </a:lnTo>
+                <a:lnTo>
+                  <a:pt x="2857500" y="0"/>
+                </a:lnTo>
+                <a:lnTo>
+                  <a:pt x="4286250" y="1428750"/>
+                </a:lnTo>
+                <a:moveTo>
+                  <a:pt x="1428750" y="476250"/>
+                </a:moveTo>
+                <a:lnTo>
+                  <a:pt x="1428750" y="3333750"/>
+                </a:lnTo>
+                <a:moveTo>
+                  <a:pt x="2857500" y="0"/>
+                </a:moveTo>
+                <a:lnTo>
+                  <a:pt x="2857500" y="2857500"/>
+                </a:lnTo>
+              </a:path>
+            </a:pathLst>
+          </a:custGeom>
+          <a:noFill/>
+          <a:ln w="76200" cap="rnd">
+            <a:solidFill>
+              <a:srgbClr val="0066CC"/>
+            </a:solidFill>
+          </a:ln>
+        </p:spPr>
+      </p:sp>
+      <p:sp>
+        <p:nvSpPr>
+          <p:cNvPr id="6" name="Ellipse 6"/>
+          <p:cNvSpPr/>
+          <p:nvPr/>
+        </p:nvSpPr>
+        <p:spPr>
+          <a:xfrm>
+            <a:off x="2762250" y="2286000"/>
+            <a:ext cx="190500" cy="190500"/>
           </a:xfrm>
           <a:prstGeom prst="ellipse">
             <a:avLst/>
@@ -3997,14 +3918,14 @@
       </p:sp>
       <p:sp>
         <p:nvSpPr>
-          <p:cNvPr id="11" name="Ellipse 11"/>
+          <p:cNvPr id="7" name="Ellipse 7"/>
           <p:cNvSpPr/>
           <p:nvPr/>
         </p:nvSpPr>
         <p:spPr>
           <a:xfrm>
-            <a:off x="4210050" y="3733800"/>
-            <a:ext cx="152400" cy="152400"/>
+            <a:off x="4191000" y="1809750"/>
+            <a:ext cx="190500" cy="190500"/>
           </a:xfrm>
           <a:prstGeom prst="ellipse">
             <a:avLst/>
@@ -4019,14 +3940,14 @@
       </p:sp>
       <p:sp>
         <p:nvSpPr>
-          <p:cNvPr id="12" name="Ellipse 12"/>
+          <p:cNvPr id="8" name="Ellipse 8"/>
           <p:cNvSpPr/>
           <p:nvPr/>
         </p:nvSpPr>
         <p:spPr>
           <a:xfrm>
-            <a:off x="5162550" y="5162550"/>
-            <a:ext cx="152400" cy="152400"/>
+            <a:off x="2762250" y="5143500"/>
+            <a:ext cx="190500" cy="190500"/>
           </a:xfrm>
           <a:prstGeom prst="ellipse">
             <a:avLst/>
@@ -4041,14 +3962,36 @@
       </p:sp>
       <p:sp>
         <p:nvSpPr>
-          <p:cNvPr id="13" name="TextBox 13"/>
+          <p:cNvPr id="9" name="Rectangle 9"/>
+          <p:cNvSpPr/>
+          <p:nvPr/>
+        </p:nvSpPr>
+        <p:spPr>
+          <a:xfrm>
+            <a:off x="7010400" y="1143000"/>
+            <a:ext cx="4724400" cy="2362200"/>
+          </a:xfrm>
+          <a:prstGeom prst="rect">
+            <a:avLst/>
+          </a:prstGeom>
+          <a:solidFill>
+            <a:srgbClr val="F8F9FA"/>
+          </a:solidFill>
+          <a:ln>
+            <a:noFill/>
+          </a:ln>
+        </p:spPr>
+      </p:sp>
+      <p:sp>
+        <p:nvSpPr>
+          <p:cNvPr id="10" name="TextBox 10"/>
           <p:cNvSpPr txBox="1"/>
           <p:nvPr/>
         </p:nvSpPr>
         <p:spPr>
           <a:xfrm>
-            <a:off x="561975" y="6110288"/>
-            <a:ext cx="3748802" cy="152400"/>
+            <a:off x="7225665" y="1410652"/>
+            <a:ext cx="1983065" cy="213360"/>
           </a:xfrm>
           <a:prstGeom prst="rect">
             <a:avLst/>
@@ -4065,6 +4008,250 @@
           <a:lstStyle/>
           <a:p>
             <a:pPr algn="l"/>
+            <a:r>
+              <a:rPr lang="zh-CN" sz="1050" b="1" dirty="0">
+                <a:solidFill>
+                  <a:srgbClr val="1A1A1A"/>
+                </a:solidFill>
+                <a:latin typeface="Google Sans"/>
+                <a:ea typeface="Microsoft YaHei"/>
+                <a:cs typeface="Google Sans"/>
+              </a:rPr>
+              <a:t>ПРИОРИТЕТ И СВЯЗАННОСТЬ</a:t>
+            </a:r>
+          </a:p>
+        </p:txBody>
+      </p:sp>
+      <p:sp>
+        <p:nvSpPr>
+          <p:cNvPr id="11" name="TextBox 11"/>
+          <p:cNvSpPr txBox="1"/>
+          <p:nvPr/>
+        </p:nvSpPr>
+        <p:spPr>
+          <a:xfrm>
+            <a:off x="7227570" y="1731645"/>
+            <a:ext cx="4091083" cy="182880"/>
+          </a:xfrm>
+          <a:prstGeom prst="rect">
+            <a:avLst/>
+          </a:prstGeom>
+          <a:noFill/>
+          <a:ln>
+            <a:noFill/>
+          </a:ln>
+        </p:spPr>
+        <p:txBody>
+          <a:bodyPr wrap="none" lIns="0" tIns="0" rIns="0" bIns="0" anchor="t" anchorCtr="0">
+            <a:spAutoFit/>
+          </a:bodyPr>
+          <a:lstStyle/>
+          <a:p>
+            <a:pPr algn="l"/>
+            <a:r>
+              <a:rPr lang="zh-CN" sz="900" dirty="0">
+                <a:solidFill>
+                  <a:srgbClr val="1A1A1A"/>
+                </a:solidFill>
+                <a:latin typeface="Google Sans"/>
+                <a:ea typeface="Microsoft YaHei"/>
+                <a:cs typeface="Google Sans"/>
+              </a:rPr>
+              <a:t>Приоритет общественному транспорту через развитие сети БРТ.</a:t>
+            </a:r>
+          </a:p>
+        </p:txBody>
+      </p:sp>
+      <p:sp>
+        <p:nvSpPr>
+          <p:cNvPr id="12" name="TextBox 12"/>
+          <p:cNvSpPr txBox="1"/>
+          <p:nvPr/>
+        </p:nvSpPr>
+        <p:spPr>
+          <a:xfrm>
+            <a:off x="7227570" y="2036445"/>
+            <a:ext cx="3690176" cy="182880"/>
+          </a:xfrm>
+          <a:prstGeom prst="rect">
+            <a:avLst/>
+          </a:prstGeom>
+          <a:noFill/>
+          <a:ln>
+            <a:noFill/>
+          </a:ln>
+        </p:spPr>
+        <p:txBody>
+          <a:bodyPr wrap="none" lIns="0" tIns="0" rIns="0" bIns="0" anchor="t" anchorCtr="0">
+            <a:spAutoFit/>
+          </a:bodyPr>
+          <a:lstStyle/>
+          <a:p>
+            <a:pPr algn="l"/>
+            <a:r>
+              <a:rPr lang="zh-CN" sz="900" dirty="0">
+                <a:solidFill>
+                  <a:srgbClr val="1A1A1A"/>
+                </a:solidFill>
+                <a:latin typeface="Google Sans"/>
+                <a:ea typeface="Microsoft YaHei"/>
+                <a:cs typeface="Google Sans"/>
+              </a:rPr>
+              <a:t>Связанность линий для сокращения интервалов движения.</a:t>
+            </a:r>
+          </a:p>
+        </p:txBody>
+      </p:sp>
+      <p:sp>
+        <p:nvSpPr>
+          <p:cNvPr id="13" name="Rectangle 13"/>
+          <p:cNvSpPr/>
+          <p:nvPr/>
+        </p:nvSpPr>
+        <p:spPr>
+          <a:xfrm>
+            <a:off x="7010400" y="3733800"/>
+            <a:ext cx="4724400" cy="2667000"/>
+          </a:xfrm>
+          <a:prstGeom prst="rect">
+            <a:avLst/>
+          </a:prstGeom>
+          <a:solidFill>
+            <a:srgbClr val="F8F9FA"/>
+          </a:solidFill>
+          <a:ln>
+            <a:noFill/>
+          </a:ln>
+        </p:spPr>
+      </p:sp>
+      <p:sp>
+        <p:nvSpPr>
+          <p:cNvPr id="14" name="TextBox 14"/>
+          <p:cNvSpPr txBox="1"/>
+          <p:nvPr/>
+        </p:nvSpPr>
+        <p:spPr>
+          <a:xfrm>
+            <a:off x="7225665" y="4001452"/>
+            <a:ext cx="558036" cy="213360"/>
+          </a:xfrm>
+          <a:prstGeom prst="rect">
+            <a:avLst/>
+          </a:prstGeom>
+          <a:noFill/>
+          <a:ln>
+            <a:noFill/>
+          </a:ln>
+        </p:spPr>
+        <p:txBody>
+          <a:bodyPr wrap="none" lIns="0" tIns="0" rIns="0" bIns="0" anchor="t" anchorCtr="0">
+            <a:spAutoFit/>
+          </a:bodyPr>
+          <a:lstStyle/>
+          <a:p>
+            <a:pPr algn="l"/>
+            <a:r>
+              <a:rPr lang="zh-CN" sz="1050" b="1" dirty="0">
+                <a:solidFill>
+                  <a:srgbClr val="1A1A1A"/>
+                </a:solidFill>
+                <a:latin typeface="Google Sans"/>
+                <a:ea typeface="Microsoft YaHei"/>
+                <a:cs typeface="Google Sans"/>
+              </a:rPr>
+              <a:t>ЭФФЕКТ</a:t>
+            </a:r>
+          </a:p>
+        </p:txBody>
+      </p:sp>
+      <p:sp>
+        <p:nvSpPr>
+          <p:cNvPr id="15" name="Ellipse 15"/>
+          <p:cNvSpPr/>
+          <p:nvPr/>
+        </p:nvSpPr>
+        <p:spPr>
+          <a:xfrm>
+            <a:off x="7429500" y="4667250"/>
+            <a:ext cx="571500" cy="571500"/>
+          </a:xfrm>
+          <a:prstGeom prst="ellipse">
+            <a:avLst/>
+          </a:prstGeom>
+          <a:solidFill>
+            <a:srgbClr val="E1EFFF"/>
+          </a:solidFill>
+          <a:ln>
+            <a:noFill/>
+          </a:ln>
+        </p:spPr>
+      </p:sp>
+      <p:sp>
+        <p:nvSpPr>
+          <p:cNvPr id="16" name="TextBox 16"/>
+          <p:cNvSpPr txBox="1"/>
+          <p:nvPr/>
+        </p:nvSpPr>
+        <p:spPr>
+          <a:xfrm>
+            <a:off x="7520940" y="4834890"/>
+            <a:ext cx="190310" cy="365760"/>
+          </a:xfrm>
+          <a:prstGeom prst="rect">
+            <a:avLst/>
+          </a:prstGeom>
+          <a:noFill/>
+          <a:ln>
+            <a:noFill/>
+          </a:ln>
+        </p:spPr>
+        <p:txBody>
+          <a:bodyPr wrap="none" lIns="0" tIns="0" rIns="0" bIns="0" anchor="t" anchorCtr="0">
+            <a:spAutoFit/>
+          </a:bodyPr>
+          <a:lstStyle/>
+          <a:p>
+            <a:pPr algn="l"/>
+            <a:r>
+              <a:rPr lang="zh-CN" sz="1800" dirty="0">
+                <a:solidFill>
+                  <a:srgbClr val="0066CC"/>
+                </a:solidFill>
+                <a:latin typeface="Google Sans"/>
+                <a:ea typeface="Microsoft YaHei"/>
+                <a:cs typeface="Google Sans"/>
+              </a:rPr>
+              <a:t>🕒</a:t>
+            </a:r>
+          </a:p>
+        </p:txBody>
+      </p:sp>
+      <p:sp>
+        <p:nvSpPr>
+          <p:cNvPr id="17" name="TextBox 17"/>
+          <p:cNvSpPr txBox="1"/>
+          <p:nvPr/>
+        </p:nvSpPr>
+        <p:spPr>
+          <a:xfrm>
+            <a:off x="6913602" y="5405438"/>
+            <a:ext cx="955596" cy="152400"/>
+          </a:xfrm>
+          <a:prstGeom prst="rect">
+            <a:avLst/>
+          </a:prstGeom>
+          <a:noFill/>
+          <a:ln>
+            <a:noFill/>
+          </a:ln>
+        </p:spPr>
+        <p:txBody>
+          <a:bodyPr wrap="none" lIns="0" tIns="0" rIns="0" bIns="0" anchor="t" anchorCtr="0">
+            <a:spAutoFit/>
+          </a:bodyPr>
+          <a:lstStyle/>
+          <a:p>
+            <a:pPr algn="ctr"/>
             <a:r>
               <a:rPr lang="zh-CN" sz="750" dirty="0">
                 <a:solidFill>
@@ -4074,27 +4261,27 @@
                 <a:ea typeface="Microsoft YaHei"/>
                 <a:cs typeface="Google Sans"/>
               </a:rPr>
-              <a:t>Proposed network expansion (Blue) vs existing infrastructure (Grey)</a:t>
-            </a:r>
-          </a:p>
-        </p:txBody>
-      </p:sp>
-      <p:sp>
-        <p:nvSpPr>
-          <p:cNvPr id="14" name="Rectangle 14"/>
+              <a:t>Экономия времени</a:t>
+            </a:r>
+          </a:p>
+        </p:txBody>
+      </p:sp>
+      <p:sp>
+        <p:nvSpPr>
+          <p:cNvPr id="18" name="Ellipse 18"/>
           <p:cNvSpPr/>
           <p:nvPr/>
         </p:nvSpPr>
         <p:spPr>
           <a:xfrm>
-            <a:off x="6924675" y="1143000"/>
-            <a:ext cx="4819650" cy="2476500"/>
-          </a:xfrm>
-          <a:prstGeom prst="rect">
+            <a:off x="9077325" y="4667250"/>
+            <a:ext cx="571500" cy="571500"/>
+          </a:xfrm>
+          <a:prstGeom prst="ellipse">
             <a:avLst/>
           </a:prstGeom>
           <a:solidFill>
-            <a:srgbClr val="F8F9FA"/>
+            <a:srgbClr val="E1EFFF"/>
           </a:solidFill>
           <a:ln>
             <a:noFill/>
@@ -4103,14 +4290,14 @@
       </p:sp>
       <p:sp>
         <p:nvSpPr>
-          <p:cNvPr id="15" name="TextBox 15"/>
+          <p:cNvPr id="19" name="TextBox 19"/>
           <p:cNvSpPr txBox="1"/>
           <p:nvPr/>
         </p:nvSpPr>
         <p:spPr>
           <a:xfrm>
-            <a:off x="7139940" y="1458278"/>
-            <a:ext cx="1709330" cy="213360"/>
+            <a:off x="9197340" y="4834890"/>
+            <a:ext cx="190310" cy="365760"/>
           </a:xfrm>
           <a:prstGeom prst="rect">
             <a:avLst/>
@@ -4128,29 +4315,29 @@
           <a:p>
             <a:pPr algn="l"/>
             <a:r>
-              <a:rPr lang="zh-CN" sz="1050" b="1" dirty="0">
+              <a:rPr lang="zh-CN" sz="1800" dirty="0">
                 <a:solidFill>
-                  <a:srgbClr val="1A1A1A"/>
+                  <a:srgbClr val="0066CC"/>
                 </a:solidFill>
                 <a:latin typeface="Google Sans"/>
                 <a:ea typeface="Microsoft YaHei"/>
                 <a:cs typeface="Google Sans"/>
               </a:rPr>
-              <a:t>INTEGRATION STRATEGY</a:t>
-            </a:r>
-          </a:p>
-        </p:txBody>
-      </p:sp>
-      <p:sp>
-        <p:nvSpPr>
-          <p:cNvPr id="16" name="TextBox 16"/>
+              <a:t>🚌</a:t>
+            </a:r>
+          </a:p>
+        </p:txBody>
+      </p:sp>
+      <p:sp>
+        <p:nvSpPr>
+          <p:cNvPr id="20" name="TextBox 20"/>
           <p:cNvSpPr txBox="1"/>
           <p:nvPr/>
         </p:nvSpPr>
         <p:spPr>
           <a:xfrm>
-            <a:off x="7141845" y="1807844"/>
-            <a:ext cx="3370679" cy="276999"/>
+            <a:off x="8774311" y="5405438"/>
+            <a:ext cx="1196578" cy="152400"/>
           </a:xfrm>
           <a:prstGeom prst="rect">
             <a:avLst/>
@@ -4161,42 +4348,42 @@
           </a:ln>
         </p:spPr>
         <p:txBody>
-          <a:bodyPr wrap="square" lIns="0" tIns="0" rIns="0" bIns="0" anchor="t" anchorCtr="0">
+          <a:bodyPr wrap="none" lIns="0" tIns="0" rIns="0" bIns="0" anchor="t" anchorCtr="0">
             <a:spAutoFit/>
           </a:bodyPr>
           <a:lstStyle/>
           <a:p>
-            <a:pPr algn="l"/>
-            <a:r>
-              <a:rPr lang="zh-CN" sz="900" dirty="0">
+            <a:pPr algn="ctr"/>
+            <a:r>
+              <a:rPr lang="zh-CN" sz="750" dirty="0">
                 <a:solidFill>
-                  <a:srgbClr val="1A1A1A"/>
+                  <a:srgbClr val="808080"/>
                 </a:solidFill>
                 <a:latin typeface="Google Sans"/>
                 <a:ea typeface="Microsoft YaHei"/>
                 <a:cs typeface="Google Sans"/>
               </a:rPr>
-              <a:t>Integrating existing BRT corridors with new dedicated bus lanesto eliminate bottlenecks and ensure seamless transfers.</a:t>
-            </a:r>
-          </a:p>
-        </p:txBody>
-      </p:sp>
-      <p:sp>
-        <p:nvSpPr>
-          <p:cNvPr id="17" name="Rectangle 17"/>
+              <a:t>Рост пассажиропотока</a:t>
+            </a:r>
+          </a:p>
+        </p:txBody>
+      </p:sp>
+      <p:sp>
+        <p:nvSpPr>
+          <p:cNvPr id="21" name="Ellipse 21"/>
           <p:cNvSpPr/>
           <p:nvPr/>
         </p:nvSpPr>
         <p:spPr>
           <a:xfrm>
-            <a:off x="6924675" y="3810000"/>
-            <a:ext cx="4819650" cy="2600325"/>
-          </a:xfrm>
-          <a:prstGeom prst="rect">
+            <a:off x="10725150" y="4667250"/>
+            <a:ext cx="571500" cy="571500"/>
+          </a:xfrm>
+          <a:prstGeom prst="ellipse">
             <a:avLst/>
           </a:prstGeom>
           <a:solidFill>
-            <a:srgbClr val="F8F9FA"/>
+            <a:srgbClr val="E1EFFF"/>
           </a:solidFill>
           <a:ln>
             <a:noFill/>
@@ -4205,14 +4392,14 @@
       </p:sp>
       <p:sp>
         <p:nvSpPr>
-          <p:cNvPr id="18" name="TextBox 18"/>
+          <p:cNvPr id="22" name="TextBox 22"/>
           <p:cNvSpPr txBox="1"/>
           <p:nvPr/>
         </p:nvSpPr>
         <p:spPr>
           <a:xfrm>
-            <a:off x="7139940" y="4125278"/>
-            <a:ext cx="1282627" cy="213360"/>
+            <a:off x="10873740" y="4834890"/>
+            <a:ext cx="190310" cy="365760"/>
           </a:xfrm>
           <a:prstGeom prst="rect">
             <a:avLst/>
@@ -4230,29 +4417,29 @@
           <a:p>
             <a:pPr algn="l"/>
             <a:r>
-              <a:rPr lang="zh-CN" sz="1050" b="1" dirty="0">
+              <a:rPr lang="zh-CN" sz="1800" dirty="0">
                 <a:solidFill>
-                  <a:srgbClr val="1A1A1A"/>
+                  <a:srgbClr val="0066CC"/>
                 </a:solidFill>
                 <a:latin typeface="Google Sans"/>
                 <a:ea typeface="Microsoft YaHei"/>
                 <a:cs typeface="Google Sans"/>
               </a:rPr>
-              <a:t>NETWORK IMPACT</a:t>
-            </a:r>
-          </a:p>
-        </p:txBody>
-      </p:sp>
-      <p:sp>
-        <p:nvSpPr>
-          <p:cNvPr id="19" name="TextBox 19"/>
+              <a:t>📈</a:t>
+            </a:r>
+          </a:p>
+        </p:txBody>
+      </p:sp>
+      <p:sp>
+        <p:nvSpPr>
+          <p:cNvPr id="23" name="TextBox 23"/>
           <p:cNvSpPr txBox="1"/>
           <p:nvPr/>
         </p:nvSpPr>
         <p:spPr>
           <a:xfrm>
-            <a:off x="7141845" y="4474844"/>
-            <a:ext cx="4448175" cy="276999"/>
+            <a:off x="10525125" y="5405438"/>
+            <a:ext cx="895350" cy="152400"/>
           </a:xfrm>
           <a:prstGeom prst="rect">
             <a:avLst/>
@@ -4263,22 +4450,22 @@
           </a:ln>
         </p:spPr>
         <p:txBody>
-          <a:bodyPr wrap="square" lIns="0" tIns="0" rIns="0" bIns="0" anchor="t" anchorCtr="0">
+          <a:bodyPr wrap="none" lIns="0" tIns="0" rIns="0" bIns="0" anchor="t" anchorCtr="0">
             <a:spAutoFit/>
           </a:bodyPr>
           <a:lstStyle/>
           <a:p>
-            <a:pPr algn="l"/>
-            <a:r>
-              <a:rPr lang="zh-CN" sz="900" dirty="0">
+            <a:pPr algn="ctr"/>
+            <a:r>
+              <a:rPr lang="zh-CN" sz="750" dirty="0">
                 <a:solidFill>
-                  <a:srgbClr val="1A1A1A"/>
+                  <a:srgbClr val="808080"/>
                 </a:solidFill>
                 <a:latin typeface="Google Sans"/>
                 <a:ea typeface="Microsoft YaHei"/>
                 <a:cs typeface="Google Sans"/>
               </a:rPr>
-              <a:t>• Focus on network connectivity across urban zones.• Reduced intervals through synchronized scheduling.• Enhanced passenger throughput during peak hours.</a:t>
+              <a:t>Надежность сети</a:t>
             </a:r>
           </a:p>
         </p:txBody>
@@ -4316,7 +4503,7 @@
         </p:nvSpPr>
         <p:spPr>
           <a:xfrm>
-            <a:off x="0" y="0"/>
+            <a:off x="447675" y="447675"/>
             <a:ext cx="12192000" cy="6858000"/>
           </a:xfrm>
           <a:prstGeom prst="rect">
@@ -4338,8 +4525,8 @@
         </p:nvSpPr>
         <p:spPr>
           <a:xfrm>
-            <a:off x="424815" y="615315"/>
-            <a:ext cx="3979212" cy="365760"/>
+            <a:off x="434340" y="643890"/>
+            <a:ext cx="5386988" cy="365760"/>
           </a:xfrm>
           <a:prstGeom prst="rect">
             <a:avLst/>
@@ -4365,7 +4552,7 @@
                 <a:ea typeface="Microsoft YaHei"/>
                 <a:cs typeface="Google Sans"/>
               </a:rPr>
-              <a:t>2026 MICROMOBILITY ROADMAP</a:t>
+              <a:t>РАЗВИТИЕ МИКРОМОБИЛЬНОСТИ К 2026 ГОДУ</a:t>
             </a:r>
           </a:p>
         </p:txBody>
@@ -4378,8 +4565,8 @@
         </p:nvSpPr>
         <p:spPr>
           <a:xfrm>
-            <a:off x="447675" y="1238250"/>
-            <a:ext cx="5457825" cy="2476500"/>
+            <a:off x="457200" y="1371600"/>
+            <a:ext cx="3429000" cy="2133600"/>
           </a:xfrm>
           <a:prstGeom prst="rect">
             <a:avLst/>
@@ -4394,80 +4581,54 @@
       </p:sp>
       <p:sp>
         <p:nvSpPr>
-          <p:cNvPr id="5" name="Rectangle 5"/>
-          <p:cNvSpPr/>
-          <p:nvPr/>
-        </p:nvSpPr>
-        <p:spPr>
-          <a:xfrm>
-            <a:off x="6286500" y="1238250"/>
-            <a:ext cx="5457825" cy="2476500"/>
+          <p:cNvPr id="5" name="TextBox 5"/>
+          <p:cNvSpPr txBox="1"/>
+          <p:nvPr/>
+        </p:nvSpPr>
+        <p:spPr>
+          <a:xfrm>
+            <a:off x="643890" y="1548765"/>
+            <a:ext cx="1348978" cy="670560"/>
           </a:xfrm>
           <a:prstGeom prst="rect">
             <a:avLst/>
           </a:prstGeom>
-          <a:solidFill>
-            <a:srgbClr val="F8F9FA"/>
-          </a:solidFill>
+          <a:noFill/>
           <a:ln>
             <a:noFill/>
           </a:ln>
         </p:spPr>
-      </p:sp>
-      <p:sp>
-        <p:nvSpPr>
-          <p:cNvPr id="6" name="Rectangle 6"/>
-          <p:cNvSpPr/>
-          <p:nvPr/>
-        </p:nvSpPr>
-        <p:spPr>
-          <a:xfrm>
-            <a:off x="447675" y="3905250"/>
-            <a:ext cx="5457825" cy="2476500"/>
-          </a:xfrm>
-          <a:prstGeom prst="rect">
-            <a:avLst/>
-          </a:prstGeom>
-          <a:solidFill>
-            <a:srgbClr val="F8F9FA"/>
-          </a:solidFill>
-          <a:ln>
-            <a:noFill/>
-          </a:ln>
-        </p:spPr>
-      </p:sp>
-      <p:sp>
-        <p:nvSpPr>
-          <p:cNvPr id="7" name="Rectangle 7"/>
-          <p:cNvSpPr/>
-          <p:nvPr/>
-        </p:nvSpPr>
-        <p:spPr>
-          <a:xfrm>
-            <a:off x="6286500" y="3905250"/>
-            <a:ext cx="5457825" cy="2476500"/>
-          </a:xfrm>
-          <a:prstGeom prst="rect">
-            <a:avLst/>
-          </a:prstGeom>
-          <a:solidFill>
-            <a:srgbClr val="F8F9FA"/>
-          </a:solidFill>
-          <a:ln>
-            <a:noFill/>
-          </a:ln>
-        </p:spPr>
-      </p:sp>
-      <p:sp>
-        <p:nvSpPr>
-          <p:cNvPr id="8" name="TextBox 8"/>
+        <p:txBody>
+          <a:bodyPr wrap="none" lIns="0" tIns="0" rIns="0" bIns="0" anchor="t" anchorCtr="0">
+            <a:spAutoFit/>
+          </a:bodyPr>
+          <a:lstStyle/>
+          <a:p>
+            <a:pPr algn="l"/>
+            <a:r>
+              <a:rPr lang="zh-CN" sz="3300" b="1" dirty="0">
+                <a:solidFill>
+                  <a:srgbClr val="0066CC"/>
+                </a:solidFill>
+                <a:latin typeface="Google Sans"/>
+                <a:ea typeface="Microsoft YaHei"/>
+                <a:cs typeface="Google Sans"/>
+              </a:rPr>
+              <a:t>55 км</a:t>
+            </a:r>
+          </a:p>
+        </p:txBody>
+      </p:sp>
+      <p:sp>
+        <p:nvSpPr>
+          <p:cNvPr id="6" name="TextBox 6"/>
           <p:cNvSpPr txBox="1"/>
           <p:nvPr/>
         </p:nvSpPr>
         <p:spPr>
           <a:xfrm>
-            <a:off x="662940" y="1553528"/>
-            <a:ext cx="1226270" cy="213360"/>
+            <a:off x="672465" y="2172652"/>
+            <a:ext cx="1314831" cy="213360"/>
           </a:xfrm>
           <a:prstGeom prst="rect">
             <a:avLst/>
@@ -4493,21 +4654,127 @@
                 <a:ea typeface="Microsoft YaHei"/>
                 <a:cs typeface="Google Sans"/>
               </a:rPr>
-              <a:t>INFRASTRUCTURE</a:t>
-            </a:r>
-          </a:p>
-        </p:txBody>
-      </p:sp>
-      <p:sp>
-        <p:nvSpPr>
-          <p:cNvPr id="9" name="TextBox 9"/>
+              <a:t>Новых велополос</a:t>
+            </a:r>
+          </a:p>
+        </p:txBody>
+      </p:sp>
+      <p:sp>
+        <p:nvSpPr>
+          <p:cNvPr id="7" name="TextBox 7"/>
           <p:cNvSpPr txBox="1"/>
           <p:nvPr/>
         </p:nvSpPr>
         <p:spPr>
           <a:xfrm>
-            <a:off x="634365" y="1834515"/>
-            <a:ext cx="1298372" cy="670560"/>
+            <a:off x="674370" y="2493645"/>
+            <a:ext cx="4781169" cy="182880"/>
+          </a:xfrm>
+          <a:prstGeom prst="rect">
+            <a:avLst/>
+          </a:prstGeom>
+          <a:noFill/>
+          <a:ln>
+            <a:noFill/>
+          </a:ln>
+        </p:spPr>
+        <p:txBody>
+          <a:bodyPr wrap="none" lIns="0" tIns="0" rIns="0" bIns="0" anchor="t" anchorCtr="0">
+            <a:spAutoFit/>
+          </a:bodyPr>
+          <a:lstStyle/>
+          <a:p>
+            <a:pPr algn="l"/>
+            <a:r>
+              <a:rPr lang="zh-CN" sz="900" dirty="0">
+                <a:solidFill>
+                  <a:srgbClr val="1A1A1A"/>
+                </a:solidFill>
+                <a:latin typeface="Google Sans"/>
+                <a:ea typeface="Microsoft YaHei"/>
+                <a:cs typeface="Google Sans"/>
+              </a:rPr>
+              <a:t>Расширение сети безопасных маршрутов для передвижения на велосипедах.</a:t>
+            </a:r>
+          </a:p>
+        </p:txBody>
+      </p:sp>
+      <p:sp>
+        <p:nvSpPr>
+          <p:cNvPr id="8" name="Freeform 8"/>
+          <p:cNvSpPr/>
+          <p:nvPr/>
+        </p:nvSpPr>
+        <p:spPr>
+          <a:xfrm>
+            <a:off x="676275" y="2952750"/>
+            <a:ext cx="276225" cy="95250"/>
+          </a:xfrm>
+          <a:custGeom>
+            <a:avLst/>
+            <a:gdLst/>
+            <a:ahLst/>
+            <a:cxnLst/>
+            <a:rect l="l" t="t" r="r" b="b"/>
+            <a:pathLst>
+              <a:path w="276225" h="95250">
+                <a:moveTo>
+                  <a:pt x="0" y="0"/>
+                </a:moveTo>
+                <a:lnTo>
+                  <a:pt x="276225" y="0"/>
+                </a:lnTo>
+                <a:moveTo>
+                  <a:pt x="0" y="95250"/>
+                </a:moveTo>
+                <a:lnTo>
+                  <a:pt x="180975" y="95250"/>
+                </a:lnTo>
+              </a:path>
+            </a:pathLst>
+          </a:custGeom>
+          <a:solidFill>
+            <a:srgbClr val="000000"/>
+          </a:solidFill>
+          <a:ln w="38100" cap="rnd">
+            <a:solidFill>
+              <a:srgbClr val="0066CC"/>
+            </a:solidFill>
+          </a:ln>
+        </p:spPr>
+      </p:sp>
+      <p:sp>
+        <p:nvSpPr>
+          <p:cNvPr id="9" name="Rectangle 9"/>
+          <p:cNvSpPr/>
+          <p:nvPr/>
+        </p:nvSpPr>
+        <p:spPr>
+          <a:xfrm>
+            <a:off x="4419600" y="1371600"/>
+            <a:ext cx="3429000" cy="2133600"/>
+          </a:xfrm>
+          <a:prstGeom prst="rect">
+            <a:avLst/>
+          </a:prstGeom>
+          <a:solidFill>
+            <a:srgbClr val="F8F9FA"/>
+          </a:solidFill>
+          <a:ln>
+            <a:noFill/>
+          </a:ln>
+        </p:spPr>
+      </p:sp>
+      <p:sp>
+        <p:nvSpPr>
+          <p:cNvPr id="10" name="TextBox 10"/>
+          <p:cNvSpPr txBox="1"/>
+          <p:nvPr/>
+        </p:nvSpPr>
+        <p:spPr>
+          <a:xfrm>
+            <a:off x="4530090" y="1548765"/>
+            <a:ext cx="918824" cy="670560"/>
           </a:xfrm>
           <a:prstGeom prst="rect">
             <a:avLst/>
@@ -4533,21 +4800,61 @@
                 <a:ea typeface="Microsoft YaHei"/>
                 <a:cs typeface="Google Sans"/>
               </a:rPr>
-              <a:t>55km</a:t>
-            </a:r>
-          </a:p>
-        </p:txBody>
-      </p:sp>
-      <p:sp>
-        <p:nvSpPr>
-          <p:cNvPr id="10" name="TextBox 10"/>
+              <a:t>200</a:t>
+            </a:r>
+          </a:p>
+        </p:txBody>
+      </p:sp>
+      <p:sp>
+        <p:nvSpPr>
+          <p:cNvPr id="11" name="TextBox 11"/>
           <p:cNvSpPr txBox="1"/>
           <p:nvPr/>
         </p:nvSpPr>
         <p:spPr>
           <a:xfrm>
-            <a:off x="664845" y="2379345"/>
-            <a:ext cx="1619917" cy="182880"/>
+            <a:off x="4558665" y="2172652"/>
+            <a:ext cx="1491953" cy="213360"/>
+          </a:xfrm>
+          <a:prstGeom prst="rect">
+            <a:avLst/>
+          </a:prstGeom>
+          <a:noFill/>
+          <a:ln>
+            <a:noFill/>
+          </a:ln>
+        </p:spPr>
+        <p:txBody>
+          <a:bodyPr wrap="none" lIns="0" tIns="0" rIns="0" bIns="0" anchor="t" anchorCtr="0">
+            <a:spAutoFit/>
+          </a:bodyPr>
+          <a:lstStyle/>
+          <a:p>
+            <a:pPr algn="l"/>
+            <a:r>
+              <a:rPr lang="zh-CN" sz="1050" b="1" dirty="0">
+                <a:solidFill>
+                  <a:srgbClr val="1A1A1A"/>
+                </a:solidFill>
+                <a:latin typeface="Google Sans"/>
+                <a:ea typeface="Microsoft YaHei"/>
+                <a:cs typeface="Google Sans"/>
+              </a:rPr>
+              <a:t>Парковочных хабов</a:t>
+            </a:r>
+          </a:p>
+        </p:txBody>
+      </p:sp>
+      <p:sp>
+        <p:nvSpPr>
+          <p:cNvPr id="12" name="TextBox 12"/>
+          <p:cNvSpPr txBox="1"/>
+          <p:nvPr/>
+        </p:nvSpPr>
+        <p:spPr>
+          <a:xfrm>
+            <a:off x="4560570" y="2493645"/>
+            <a:ext cx="4268534" cy="182880"/>
           </a:xfrm>
           <a:prstGeom prst="rect">
             <a:avLst/>
@@ -4573,21 +4880,239 @@
                 <a:ea typeface="Microsoft YaHei"/>
                 <a:cs typeface="Google Sans"/>
               </a:rPr>
-              <a:t>New protected bike lanes</a:t>
-            </a:r>
-          </a:p>
-        </p:txBody>
-      </p:sp>
-      <p:sp>
-        <p:nvSpPr>
-          <p:cNvPr id="11" name="TextBox 11"/>
+              <a:t>Специализированные зоны для упорядоченной парковки самокатов.</a:t>
+            </a:r>
+          </a:p>
+        </p:txBody>
+      </p:sp>
+      <p:sp>
+        <p:nvSpPr>
+          <p:cNvPr id="13" name="Ellipse 13"/>
+          <p:cNvSpPr/>
+          <p:nvPr/>
+        </p:nvSpPr>
+        <p:spPr>
+          <a:xfrm>
+            <a:off x="4591050" y="2924175"/>
+            <a:ext cx="152400" cy="152400"/>
+          </a:xfrm>
+          <a:prstGeom prst="ellipse">
+            <a:avLst/>
+          </a:prstGeom>
+          <a:noFill/>
+          <a:ln w="19050">
+            <a:solidFill>
+              <a:srgbClr val="0066CC"/>
+            </a:solidFill>
+          </a:ln>
+        </p:spPr>
+      </p:sp>
+      <p:sp>
+        <p:nvSpPr>
+          <p:cNvPr id="14" name="Ellipse 14"/>
+          <p:cNvSpPr/>
+          <p:nvPr/>
+        </p:nvSpPr>
+        <p:spPr>
+          <a:xfrm>
+            <a:off x="4781550" y="2924175"/>
+            <a:ext cx="152400" cy="152400"/>
+          </a:xfrm>
+          <a:prstGeom prst="ellipse">
+            <a:avLst/>
+          </a:prstGeom>
+          <a:noFill/>
+          <a:ln w="19050">
+            <a:solidFill>
+              <a:srgbClr val="0066CC"/>
+            </a:solidFill>
+          </a:ln>
+        </p:spPr>
+      </p:sp>
+      <p:sp>
+        <p:nvSpPr>
+          <p:cNvPr id="15" name="Rectangle 15"/>
+          <p:cNvSpPr/>
+          <p:nvPr/>
+        </p:nvSpPr>
+        <p:spPr>
+          <a:xfrm>
+            <a:off x="8305800" y="1371600"/>
+            <a:ext cx="3429000" cy="2133600"/>
+          </a:xfrm>
+          <a:prstGeom prst="rect">
+            <a:avLst/>
+          </a:prstGeom>
+          <a:solidFill>
+            <a:srgbClr val="F8F9FA"/>
+          </a:solidFill>
+          <a:ln>
+            <a:noFill/>
+          </a:ln>
+        </p:spPr>
+      </p:sp>
+      <p:sp>
+        <p:nvSpPr>
+          <p:cNvPr id="16" name="TextBox 16"/>
           <p:cNvSpPr txBox="1"/>
           <p:nvPr/>
         </p:nvSpPr>
         <p:spPr>
           <a:xfrm>
-            <a:off x="666750" y="2586038"/>
-            <a:ext cx="2511028" cy="152400"/>
+            <a:off x="8521065" y="1563052"/>
+            <a:ext cx="1846197" cy="213360"/>
+          </a:xfrm>
+          <a:prstGeom prst="rect">
+            <a:avLst/>
+          </a:prstGeom>
+          <a:noFill/>
+          <a:ln>
+            <a:noFill/>
+          </a:ln>
+        </p:spPr>
+        <p:txBody>
+          <a:bodyPr wrap="none" lIns="0" tIns="0" rIns="0" bIns="0" anchor="t" anchorCtr="0">
+            <a:spAutoFit/>
+          </a:bodyPr>
+          <a:lstStyle/>
+          <a:p>
+            <a:pPr algn="l"/>
+            <a:r>
+              <a:rPr lang="zh-CN" sz="1050" b="1" dirty="0">
+                <a:solidFill>
+                  <a:srgbClr val="1A1A1A"/>
+                </a:solidFill>
+                <a:latin typeface="Google Sans"/>
+                <a:ea typeface="Microsoft YaHei"/>
+                <a:cs typeface="Google Sans"/>
+              </a:rPr>
+              <a:t>Цифровизация контроля</a:t>
+            </a:r>
+          </a:p>
+        </p:txBody>
+      </p:sp>
+      <p:sp>
+        <p:nvSpPr>
+          <p:cNvPr id="17" name="TextBox 17"/>
+          <p:cNvSpPr txBox="1"/>
+          <p:nvPr/>
+        </p:nvSpPr>
+        <p:spPr>
+          <a:xfrm>
+            <a:off x="8522970" y="1884045"/>
+            <a:ext cx="5182076" cy="182880"/>
+          </a:xfrm>
+          <a:prstGeom prst="rect">
+            <a:avLst/>
+          </a:prstGeom>
+          <a:noFill/>
+          <a:ln>
+            <a:noFill/>
+          </a:ln>
+        </p:spPr>
+        <p:txBody>
+          <a:bodyPr wrap="none" lIns="0" tIns="0" rIns="0" bIns="0" anchor="t" anchorCtr="0">
+            <a:spAutoFit/>
+          </a:bodyPr>
+          <a:lstStyle/>
+          <a:p>
+            <a:pPr algn="l"/>
+            <a:r>
+              <a:rPr lang="zh-CN" sz="900" dirty="0">
+                <a:solidFill>
+                  <a:srgbClr val="1A1A1A"/>
+                </a:solidFill>
+                <a:latin typeface="Google Sans"/>
+                <a:ea typeface="Microsoft YaHei"/>
+                <a:cs typeface="Google Sans"/>
+              </a:rPr>
+              <a:t>Внедрение систем мониторинга и оперативной обратной связи от пользователей.</a:t>
+            </a:r>
+          </a:p>
+        </p:txBody>
+      </p:sp>
+      <p:sp>
+        <p:nvSpPr>
+          <p:cNvPr id="18" name="Rectangle 18"/>
+          <p:cNvSpPr/>
+          <p:nvPr/>
+        </p:nvSpPr>
+        <p:spPr>
+          <a:xfrm>
+            <a:off x="8543925" y="2381250"/>
+            <a:ext cx="381000" cy="381000"/>
+          </a:xfrm>
+          <a:prstGeom prst="rect">
+            <a:avLst/>
+          </a:prstGeom>
+          <a:solidFill>
+            <a:srgbClr val="E1EFFF"/>
+          </a:solidFill>
+          <a:ln>
+            <a:noFill/>
+          </a:ln>
+        </p:spPr>
+      </p:sp>
+      <p:sp>
+        <p:nvSpPr>
+          <p:cNvPr id="19" name="Freeform 19"/>
+          <p:cNvSpPr/>
+          <p:nvPr/>
+        </p:nvSpPr>
+        <p:spPr>
+          <a:xfrm>
+            <a:off x="8639175" y="2476500"/>
+            <a:ext cx="190500" cy="190500"/>
+          </a:xfrm>
+          <a:custGeom>
+            <a:avLst/>
+            <a:gdLst/>
+            <a:ahLst/>
+            <a:cxnLst/>
+            <a:rect l="l" t="t" r="r" b="b"/>
+            <a:pathLst>
+              <a:path w="190500" h="190500">
+                <a:moveTo>
+                  <a:pt x="0" y="0"/>
+                </a:moveTo>
+                <a:lnTo>
+                  <a:pt x="190500" y="0"/>
+                </a:lnTo>
+                <a:moveTo>
+                  <a:pt x="0" y="95250"/>
+                </a:moveTo>
+                <a:lnTo>
+                  <a:pt x="190500" y="95250"/>
+                </a:lnTo>
+                <a:moveTo>
+                  <a:pt x="0" y="190500"/>
+                </a:moveTo>
+                <a:lnTo>
+                  <a:pt x="95250" y="190500"/>
+                </a:lnTo>
+              </a:path>
+            </a:pathLst>
+          </a:custGeom>
+          <a:solidFill>
+            <a:srgbClr val="000000"/>
+          </a:solidFill>
+          <a:ln w="19050" cap="rnd">
+            <a:solidFill>
+              <a:srgbClr val="0066CC"/>
+            </a:solidFill>
+          </a:ln>
+        </p:spPr>
+      </p:sp>
+      <p:sp>
+        <p:nvSpPr>
+          <p:cNvPr id="20" name="TextBox 20"/>
+          <p:cNvSpPr txBox="1"/>
+          <p:nvPr/>
+        </p:nvSpPr>
+        <p:spPr>
+          <a:xfrm>
+            <a:off x="447675" y="6329362"/>
+            <a:ext cx="3595449" cy="152400"/>
           </a:xfrm>
           <a:prstGeom prst="rect">
             <a:avLst/>
@@ -4613,662 +5138,10 @@
                 <a:ea typeface="Microsoft YaHei"/>
                 <a:cs typeface="Google Sans"/>
               </a:rPr>
-              <a:t>Expanding connectivity across urban corridors</a:t>
-            </a:r>
-          </a:p>
-        </p:txBody>
-      </p:sp>
-      <p:sp>
-        <p:nvSpPr>
-          <p:cNvPr id="12" name="TextBox 12"/>
-          <p:cNvSpPr txBox="1"/>
-          <p:nvPr/>
-        </p:nvSpPr>
-        <p:spPr>
-          <a:xfrm>
-            <a:off x="6501765" y="1553528"/>
-            <a:ext cx="1008893" cy="213360"/>
-          </a:xfrm>
-          <a:prstGeom prst="rect">
-            <a:avLst/>
-          </a:prstGeom>
-          <a:noFill/>
-          <a:ln>
-            <a:noFill/>
-          </a:ln>
-        </p:spPr>
-        <p:txBody>
-          <a:bodyPr wrap="none" lIns="0" tIns="0" rIns="0" bIns="0" anchor="t" anchorCtr="0">
-            <a:spAutoFit/>
-          </a:bodyPr>
-          <a:lstStyle/>
-          <a:p>
-            <a:pPr algn="l"/>
-            <a:r>
-              <a:rPr lang="zh-CN" sz="1050" b="1" dirty="0">
-                <a:solidFill>
-                  <a:srgbClr val="1A1A1A"/>
-                </a:solidFill>
-                <a:latin typeface="Google Sans"/>
-                <a:ea typeface="Microsoft YaHei"/>
-                <a:cs typeface="Google Sans"/>
-              </a:rPr>
-              <a:t>PARKING HUBS</a:t>
-            </a:r>
-          </a:p>
-        </p:txBody>
-      </p:sp>
-      <p:sp>
-        <p:nvSpPr>
-          <p:cNvPr id="13" name="TextBox 13"/>
-          <p:cNvSpPr txBox="1"/>
-          <p:nvPr/>
-        </p:nvSpPr>
-        <p:spPr>
-          <a:xfrm>
-            <a:off x="6473190" y="1834515"/>
-            <a:ext cx="1197159" cy="670560"/>
-          </a:xfrm>
-          <a:prstGeom prst="rect">
-            <a:avLst/>
-          </a:prstGeom>
-          <a:noFill/>
-          <a:ln>
-            <a:noFill/>
-          </a:ln>
-        </p:spPr>
-        <p:txBody>
-          <a:bodyPr wrap="none" lIns="0" tIns="0" rIns="0" bIns="0" anchor="t" anchorCtr="0">
-            <a:spAutoFit/>
-          </a:bodyPr>
-          <a:lstStyle/>
-          <a:p>
-            <a:pPr algn="l"/>
-            <a:r>
-              <a:rPr lang="zh-CN" sz="3300" b="1" dirty="0">
-                <a:solidFill>
-                  <a:srgbClr val="0066CC"/>
-                </a:solidFill>
-                <a:latin typeface="Google Sans"/>
-                <a:ea typeface="Microsoft YaHei"/>
-                <a:cs typeface="Google Sans"/>
-              </a:rPr>
-              <a:t>200+</a:t>
-            </a:r>
-          </a:p>
-        </p:txBody>
-      </p:sp>
-      <p:sp>
-        <p:nvSpPr>
-          <p:cNvPr id="14" name="TextBox 14"/>
-          <p:cNvSpPr txBox="1"/>
-          <p:nvPr/>
-        </p:nvSpPr>
-        <p:spPr>
-          <a:xfrm>
-            <a:off x="6503670" y="2379345"/>
-            <a:ext cx="1554194" cy="182880"/>
-          </a:xfrm>
-          <a:prstGeom prst="rect">
-            <a:avLst/>
-          </a:prstGeom>
-          <a:noFill/>
-          <a:ln>
-            <a:noFill/>
-          </a:ln>
-        </p:spPr>
-        <p:txBody>
-          <a:bodyPr wrap="none" lIns="0" tIns="0" rIns="0" bIns="0" anchor="t" anchorCtr="0">
-            <a:spAutoFit/>
-          </a:bodyPr>
-          <a:lstStyle/>
-          <a:p>
-            <a:pPr algn="l"/>
-            <a:r>
-              <a:rPr lang="zh-CN" sz="900" dirty="0">
-                <a:solidFill>
-                  <a:srgbClr val="1A1A1A"/>
-                </a:solidFill>
-                <a:latin typeface="Google Sans"/>
-                <a:ea typeface="Microsoft YaHei"/>
-                <a:cs typeface="Google Sans"/>
-              </a:rPr>
-              <a:t>Dedicated parking zones</a:t>
-            </a:r>
-          </a:p>
-        </p:txBody>
-      </p:sp>
-      <p:sp>
-        <p:nvSpPr>
-          <p:cNvPr id="15" name="TextBox 15"/>
-          <p:cNvSpPr txBox="1"/>
-          <p:nvPr/>
-        </p:nvSpPr>
-        <p:spPr>
-          <a:xfrm>
-            <a:off x="6505575" y="2586038"/>
-            <a:ext cx="2406968" cy="152400"/>
-          </a:xfrm>
-          <a:prstGeom prst="rect">
-            <a:avLst/>
-          </a:prstGeom>
-          <a:noFill/>
-          <a:ln>
-            <a:noFill/>
-          </a:ln>
-        </p:spPr>
-        <p:txBody>
-          <a:bodyPr wrap="none" lIns="0" tIns="0" rIns="0" bIns="0" anchor="t" anchorCtr="0">
-            <a:spAutoFit/>
-          </a:bodyPr>
-          <a:lstStyle/>
-          <a:p>
-            <a:pPr algn="l"/>
-            <a:r>
-              <a:rPr lang="zh-CN" sz="750" dirty="0">
-                <a:solidFill>
-                  <a:srgbClr val="808080"/>
-                </a:solidFill>
-                <a:latin typeface="Google Sans"/>
-                <a:ea typeface="Microsoft YaHei"/>
-                <a:cs typeface="Google Sans"/>
-              </a:rPr>
-              <a:t>Reducing sidewalk clutter and improving flow</a:t>
-            </a:r>
-          </a:p>
-        </p:txBody>
-      </p:sp>
-      <p:sp>
-        <p:nvSpPr>
-          <p:cNvPr id="16" name="TextBox 16"/>
-          <p:cNvSpPr txBox="1"/>
-          <p:nvPr/>
-        </p:nvSpPr>
-        <p:spPr>
-          <a:xfrm>
-            <a:off x="662940" y="4220528"/>
-            <a:ext cx="944485" cy="213360"/>
-          </a:xfrm>
-          <a:prstGeom prst="rect">
-            <a:avLst/>
-          </a:prstGeom>
-          <a:noFill/>
-          <a:ln>
-            <a:noFill/>
-          </a:ln>
-        </p:spPr>
-        <p:txBody>
-          <a:bodyPr wrap="none" lIns="0" tIns="0" rIns="0" bIns="0" anchor="t" anchorCtr="0">
-            <a:spAutoFit/>
-          </a:bodyPr>
-          <a:lstStyle/>
-          <a:p>
-            <a:pPr algn="l"/>
-            <a:r>
-              <a:rPr lang="zh-CN" sz="1050" b="1" dirty="0">
-                <a:solidFill>
-                  <a:srgbClr val="1A1A1A"/>
-                </a:solidFill>
-                <a:latin typeface="Google Sans"/>
-                <a:ea typeface="Microsoft YaHei"/>
-                <a:cs typeface="Google Sans"/>
-              </a:rPr>
-              <a:t>REGULATORY</a:t>
-            </a:r>
-          </a:p>
-        </p:txBody>
-      </p:sp>
-      <p:sp>
-        <p:nvSpPr>
-          <p:cNvPr id="17" name="TextBox 17"/>
-          <p:cNvSpPr txBox="1"/>
-          <p:nvPr/>
-        </p:nvSpPr>
-        <p:spPr>
-          <a:xfrm>
-            <a:off x="634365" y="4501515"/>
-            <a:ext cx="1070643" cy="670560"/>
-          </a:xfrm>
-          <a:prstGeom prst="rect">
-            <a:avLst/>
-          </a:prstGeom>
-          <a:noFill/>
-          <a:ln>
-            <a:noFill/>
-          </a:ln>
-        </p:spPr>
-        <p:txBody>
-          <a:bodyPr wrap="none" lIns="0" tIns="0" rIns="0" bIns="0" anchor="t" anchorCtr="0">
-            <a:spAutoFit/>
-          </a:bodyPr>
-          <a:lstStyle/>
-          <a:p>
-            <a:pPr algn="l"/>
-            <a:r>
-              <a:rPr lang="zh-CN" sz="3300" b="1" dirty="0">
-                <a:solidFill>
-                  <a:srgbClr val="0066CC"/>
-                </a:solidFill>
-                <a:latin typeface="Google Sans"/>
-                <a:ea typeface="Microsoft YaHei"/>
-                <a:cs typeface="Google Sans"/>
-              </a:rPr>
-              <a:t>100%</a:t>
-            </a:r>
-          </a:p>
-        </p:txBody>
-      </p:sp>
-      <p:sp>
-        <p:nvSpPr>
-          <p:cNvPr id="18" name="TextBox 18"/>
-          <p:cNvSpPr txBox="1"/>
-          <p:nvPr/>
-        </p:nvSpPr>
-        <p:spPr>
-          <a:xfrm>
-            <a:off x="664845" y="5046345"/>
-            <a:ext cx="1521333" cy="182880"/>
-          </a:xfrm>
-          <a:prstGeom prst="rect">
-            <a:avLst/>
-          </a:prstGeom>
-          <a:noFill/>
-          <a:ln>
-            <a:noFill/>
-          </a:ln>
-        </p:spPr>
-        <p:txBody>
-          <a:bodyPr wrap="none" lIns="0" tIns="0" rIns="0" bIns="0" anchor="t" anchorCtr="0">
-            <a:spAutoFit/>
-          </a:bodyPr>
-          <a:lstStyle/>
-          <a:p>
-            <a:pPr algn="l"/>
-            <a:r>
-              <a:rPr lang="zh-CN" sz="900" dirty="0">
-                <a:solidFill>
-                  <a:srgbClr val="1A1A1A"/>
-                </a:solidFill>
-                <a:latin typeface="Google Sans"/>
-                <a:ea typeface="Microsoft YaHei"/>
-                <a:cs typeface="Google Sans"/>
-              </a:rPr>
-              <a:t>Digital plate compliance</a:t>
-            </a:r>
-          </a:p>
-        </p:txBody>
-      </p:sp>
-      <p:sp>
-        <p:nvSpPr>
-          <p:cNvPr id="19" name="TextBox 19"/>
-          <p:cNvSpPr txBox="1"/>
-          <p:nvPr/>
-        </p:nvSpPr>
-        <p:spPr>
-          <a:xfrm>
-            <a:off x="666750" y="5253038"/>
-            <a:ext cx="2445306" cy="152400"/>
-          </a:xfrm>
-          <a:prstGeom prst="rect">
-            <a:avLst/>
-          </a:prstGeom>
-          <a:noFill/>
-          <a:ln>
-            <a:noFill/>
-          </a:ln>
-        </p:spPr>
-        <p:txBody>
-          <a:bodyPr wrap="none" lIns="0" tIns="0" rIns="0" bIns="0" anchor="t" anchorCtr="0">
-            <a:spAutoFit/>
-          </a:bodyPr>
-          <a:lstStyle/>
-          <a:p>
-            <a:pPr algn="l"/>
-            <a:r>
-              <a:rPr lang="zh-CN" sz="750" dirty="0">
-                <a:solidFill>
-                  <a:srgbClr val="808080"/>
-                </a:solidFill>
-                <a:latin typeface="Google Sans"/>
-                <a:ea typeface="Microsoft YaHei"/>
-                <a:cs typeface="Google Sans"/>
-              </a:rPr>
-              <a:t>Enhanced tracking and identification systems</a:t>
-            </a:r>
-          </a:p>
-        </p:txBody>
-      </p:sp>
-      <p:sp>
-        <p:nvSpPr>
-          <p:cNvPr id="20" name="TextBox 20"/>
-          <p:cNvSpPr txBox="1"/>
-          <p:nvPr/>
-        </p:nvSpPr>
-        <p:spPr>
-          <a:xfrm>
-            <a:off x="6501765" y="4220528"/>
-            <a:ext cx="1137709" cy="213360"/>
-          </a:xfrm>
-          <a:prstGeom prst="rect">
-            <a:avLst/>
-          </a:prstGeom>
-          <a:noFill/>
-          <a:ln>
-            <a:noFill/>
-          </a:ln>
-        </p:spPr>
-        <p:txBody>
-          <a:bodyPr wrap="none" lIns="0" tIns="0" rIns="0" bIns="0" anchor="t" anchorCtr="0">
-            <a:spAutoFit/>
-          </a:bodyPr>
-          <a:lstStyle/>
-          <a:p>
-            <a:pPr algn="l"/>
-            <a:r>
-              <a:rPr lang="zh-CN" sz="1050" b="1" dirty="0">
-                <a:solidFill>
-                  <a:srgbClr val="1A1A1A"/>
-                </a:solidFill>
-                <a:latin typeface="Google Sans"/>
-                <a:ea typeface="Microsoft YaHei"/>
-                <a:cs typeface="Google Sans"/>
-              </a:rPr>
-              <a:t>USER FEEDBACK</a:t>
-            </a:r>
-          </a:p>
-        </p:txBody>
-      </p:sp>
-      <p:sp>
-        <p:nvSpPr>
-          <p:cNvPr id="21" name="TextBox 21"/>
-          <p:cNvSpPr txBox="1"/>
-          <p:nvPr/>
-        </p:nvSpPr>
-        <p:spPr>
-          <a:xfrm>
-            <a:off x="6473190" y="4501515"/>
-            <a:ext cx="1197159" cy="670560"/>
-          </a:xfrm>
-          <a:prstGeom prst="rect">
-            <a:avLst/>
-          </a:prstGeom>
-          <a:noFill/>
-          <a:ln>
-            <a:noFill/>
-          </a:ln>
-        </p:spPr>
-        <p:txBody>
-          <a:bodyPr wrap="none" lIns="0" tIns="0" rIns="0" bIns="0" anchor="t" anchorCtr="0">
-            <a:spAutoFit/>
-          </a:bodyPr>
-          <a:lstStyle/>
-          <a:p>
-            <a:pPr algn="l"/>
-            <a:r>
-              <a:rPr lang="zh-CN" sz="3300" b="1" dirty="0">
-                <a:solidFill>
-                  <a:srgbClr val="0066CC"/>
-                </a:solidFill>
-                <a:latin typeface="Google Sans"/>
-                <a:ea typeface="Microsoft YaHei"/>
-                <a:cs typeface="Google Sans"/>
-              </a:rPr>
-              <a:t>24/7</a:t>
-            </a:r>
-          </a:p>
-        </p:txBody>
-      </p:sp>
-      <p:sp>
-        <p:nvSpPr>
-          <p:cNvPr id="22" name="TextBox 22"/>
-          <p:cNvSpPr txBox="1"/>
-          <p:nvPr/>
-        </p:nvSpPr>
-        <p:spPr>
-          <a:xfrm>
-            <a:off x="6503670" y="5046345"/>
-            <a:ext cx="1573911" cy="182880"/>
-          </a:xfrm>
-          <a:prstGeom prst="rect">
-            <a:avLst/>
-          </a:prstGeom>
-          <a:noFill/>
-          <a:ln>
-            <a:noFill/>
-          </a:ln>
-        </p:spPr>
-        <p:txBody>
-          <a:bodyPr wrap="none" lIns="0" tIns="0" rIns="0" bIns="0" anchor="t" anchorCtr="0">
-            <a:spAutoFit/>
-          </a:bodyPr>
-          <a:lstStyle/>
-          <a:p>
-            <a:pPr algn="l"/>
-            <a:r>
-              <a:rPr lang="zh-CN" sz="900" dirty="0">
-                <a:solidFill>
-                  <a:srgbClr val="1A1A1A"/>
-                </a:solidFill>
-                <a:latin typeface="Google Sans"/>
-                <a:ea typeface="Microsoft YaHei"/>
-                <a:cs typeface="Google Sans"/>
-              </a:rPr>
-              <a:t>Automated bot response</a:t>
-            </a:r>
-          </a:p>
-        </p:txBody>
-      </p:sp>
-      <p:sp>
-        <p:nvSpPr>
-          <p:cNvPr id="23" name="TextBox 23"/>
-          <p:cNvSpPr txBox="1"/>
-          <p:nvPr/>
-        </p:nvSpPr>
-        <p:spPr>
-          <a:xfrm>
-            <a:off x="6505575" y="5253038"/>
-            <a:ext cx="2176939" cy="152400"/>
-          </a:xfrm>
-          <a:prstGeom prst="rect">
-            <a:avLst/>
-          </a:prstGeom>
-          <a:noFill/>
-          <a:ln>
-            <a:noFill/>
-          </a:ln>
-        </p:spPr>
-        <p:txBody>
-          <a:bodyPr wrap="none" lIns="0" tIns="0" rIns="0" bIns="0" anchor="t" anchorCtr="0">
-            <a:spAutoFit/>
-          </a:bodyPr>
-          <a:lstStyle/>
-          <a:p>
-            <a:pPr algn="l"/>
-            <a:r>
-              <a:rPr lang="zh-CN" sz="750" dirty="0">
-                <a:solidFill>
-                  <a:srgbClr val="808080"/>
-                </a:solidFill>
-                <a:latin typeface="Google Sans"/>
-                <a:ea typeface="Microsoft YaHei"/>
-                <a:cs typeface="Google Sans"/>
-              </a:rPr>
-              <a:t>Real-time issue reporting and resolution</a:t>
-            </a:r>
-          </a:p>
-        </p:txBody>
-      </p:sp>
-      <p:sp>
-        <p:nvSpPr>
-          <p:cNvPr id="24" name="Freeform 24"/>
-          <p:cNvSpPr/>
-          <p:nvPr/>
-        </p:nvSpPr>
-        <p:spPr>
-          <a:xfrm>
-            <a:off x="5238750" y="1619250"/>
-            <a:ext cx="285750" cy="285750"/>
-          </a:xfrm>
-          <a:custGeom>
-            <a:avLst/>
-            <a:gdLst/>
-            <a:ahLst/>
-            <a:cxnLst/>
-            <a:rect l="l" t="t" r="r" b="b"/>
-            <a:pathLst>
-              <a:path w="285750" h="285750">
-                <a:moveTo>
-                  <a:pt x="0" y="0"/>
-                </a:moveTo>
-                <a:lnTo>
-                  <a:pt x="285750" y="0"/>
-                </a:lnTo>
-                <a:lnTo>
-                  <a:pt x="285750" y="285750"/>
-                </a:lnTo>
-                <a:lnTo>
-                  <a:pt x="0" y="285750"/>
-                </a:lnTo>
-                <a:close/>
-              </a:path>
-            </a:pathLst>
-          </a:custGeom>
-          <a:noFill/>
-          <a:ln w="19050">
-            <a:solidFill>
-              <a:srgbClr val="0066CC"/>
-            </a:solidFill>
-          </a:ln>
-        </p:spPr>
-      </p:sp>
-      <p:sp>
-        <p:nvSpPr>
-          <p:cNvPr id="25" name="Freeform 25"/>
-          <p:cNvSpPr/>
-          <p:nvPr/>
-        </p:nvSpPr>
-        <p:spPr>
-          <a:xfrm>
-            <a:off x="11049000" y="1619250"/>
-            <a:ext cx="285750" cy="285750"/>
-          </a:xfrm>
-          <a:custGeom>
-            <a:avLst/>
-            <a:gdLst/>
-            <a:ahLst/>
-            <a:cxnLst/>
-            <a:rect l="l" t="t" r="r" b="b"/>
-            <a:pathLst>
-              <a:path w="285750" h="285750">
-                <a:moveTo>
-                  <a:pt x="0" y="0"/>
-                </a:moveTo>
-                <a:lnTo>
-                  <a:pt x="285750" y="0"/>
-                </a:lnTo>
-                <a:lnTo>
-                  <a:pt x="285750" y="285750"/>
-                </a:lnTo>
-                <a:lnTo>
-                  <a:pt x="0" y="285750"/>
-                </a:lnTo>
-                <a:close/>
-              </a:path>
-            </a:pathLst>
-          </a:custGeom>
-          <a:noFill/>
-          <a:ln w="19050">
-            <a:solidFill>
-              <a:srgbClr val="0066CC"/>
-            </a:solidFill>
-          </a:ln>
-        </p:spPr>
-      </p:sp>
-      <p:sp>
-        <p:nvSpPr>
-          <p:cNvPr id="26" name="Freeform 26"/>
-          <p:cNvSpPr/>
-          <p:nvPr/>
-        </p:nvSpPr>
-        <p:spPr>
-          <a:xfrm>
-            <a:off x="5238750" y="4286250"/>
-            <a:ext cx="285750" cy="285750"/>
-          </a:xfrm>
-          <a:custGeom>
-            <a:avLst/>
-            <a:gdLst/>
-            <a:ahLst/>
-            <a:cxnLst/>
-            <a:rect l="l" t="t" r="r" b="b"/>
-            <a:pathLst>
-              <a:path w="285750" h="285750">
-                <a:moveTo>
-                  <a:pt x="0" y="0"/>
-                </a:moveTo>
-                <a:lnTo>
-                  <a:pt x="285750" y="0"/>
-                </a:lnTo>
-                <a:lnTo>
-                  <a:pt x="285750" y="285750"/>
-                </a:lnTo>
-                <a:lnTo>
-                  <a:pt x="0" y="285750"/>
-                </a:lnTo>
-                <a:close/>
-              </a:path>
-            </a:pathLst>
-          </a:custGeom>
-          <a:noFill/>
-          <a:ln w="19050">
-            <a:solidFill>
-              <a:srgbClr val="0066CC"/>
-            </a:solidFill>
-          </a:ln>
-        </p:spPr>
-      </p:sp>
-      <p:sp>
-        <p:nvSpPr>
-          <p:cNvPr id="27" name="Freeform 27"/>
-          <p:cNvSpPr/>
-          <p:nvPr/>
-        </p:nvSpPr>
-        <p:spPr>
-          <a:xfrm>
-            <a:off x="11049000" y="4286250"/>
-            <a:ext cx="285750" cy="285750"/>
-          </a:xfrm>
-          <a:custGeom>
-            <a:avLst/>
-            <a:gdLst/>
-            <a:ahLst/>
-            <a:cxnLst/>
-            <a:rect l="l" t="t" r="r" b="b"/>
-            <a:pathLst>
-              <a:path w="285750" h="285750">
-                <a:moveTo>
-                  <a:pt x="0" y="0"/>
-                </a:moveTo>
-                <a:lnTo>
-                  <a:pt x="285750" y="0"/>
-                </a:lnTo>
-                <a:lnTo>
-                  <a:pt x="285750" y="285750"/>
-                </a:lnTo>
-                <a:lnTo>
-                  <a:pt x="0" y="285750"/>
-                </a:lnTo>
-                <a:close/>
-              </a:path>
-            </a:pathLst>
-          </a:custGeom>
-          <a:noFill/>
-          <a:ln w="19050">
-            <a:solidFill>
-              <a:srgbClr val="0066CC"/>
-            </a:solidFill>
-          </a:ln>
-        </p:spPr>
+              <a:t>Слайд 2 | Стратегический план развития городской инфраструктуры</a:t>
+            </a:r>
+          </a:p>
+        </p:txBody>
       </p:sp>
     </p:spTree>
   </p:cSld>

</xml_diff>

<commit_message>
Update CLAUDE.md + TASKS.md — full project state after phases 0-4
</commit_message>
<xml_diff>
--- a/output/redesigned_test_maps.pptx
+++ b/output/redesigned_test_maps.pptx
@@ -3108,8 +3108,10 @@
             <a:off x="447675" y="447675"/>
             <a:ext cx="12192000" cy="6858000"/>
           </a:xfrm>
-          <a:prstGeom prst="rect">
-            <a:avLst/>
+          <a:prstGeom prst="roundRect">
+            <a:avLst>
+              <a:gd name="adj" fmla="val 5000"/>
+            </a:avLst>
           </a:prstGeom>
           <a:solidFill>
             <a:srgbClr val="FFFFFF"/>
@@ -3118,6 +3120,10 @@
             <a:noFill/>
           </a:ln>
         </p:spPr>
+        <p:txBody>
+          <a:bodyPr lIns="0" rIns="0" tIns="0" bIns="0" wrap="square"/>
+          <a:p/>
+        </p:txBody>
       </p:sp>
       <p:sp>
         <p:nvSpPr>
@@ -3139,7 +3145,7 @@
           </a:ln>
         </p:spPr>
         <p:txBody>
-          <a:bodyPr wrap="none" lIns="0" tIns="0" rIns="0" bIns="0" anchor="t" anchorCtr="0">
+          <a:bodyPr wrap="square" lIns="0" tIns="0" rIns="0" bIns="0" anchor="t" anchorCtr="0">
             <a:spAutoFit/>
           </a:bodyPr>
           <a:lstStyle/>
@@ -3170,8 +3176,10 @@
             <a:off x="457200" y="1143000"/>
             <a:ext cx="3352800" cy="1447800"/>
           </a:xfrm>
-          <a:prstGeom prst="rect">
-            <a:avLst/>
+          <a:prstGeom prst="roundRect">
+            <a:avLst>
+              <a:gd name="adj" fmla="val 5000"/>
+            </a:avLst>
           </a:prstGeom>
           <a:solidFill>
             <a:srgbClr val="F8F9FA"/>
@@ -3180,6 +3188,10 @@
             <a:noFill/>
           </a:ln>
         </p:spPr>
+        <p:txBody>
+          <a:bodyPr lIns="0" rIns="0" tIns="0" bIns="0" wrap="square"/>
+          <a:p/>
+        </p:txBody>
       </p:sp>
       <p:sp>
         <p:nvSpPr>
@@ -3201,7 +3213,7 @@
           </a:ln>
         </p:spPr>
         <p:txBody>
-          <a:bodyPr wrap="none" lIns="0" tIns="0" rIns="0" bIns="0" anchor="t" anchorCtr="0">
+          <a:bodyPr wrap="square" lIns="0" tIns="0" rIns="0" bIns="0" anchor="t" anchorCtr="0">
             <a:spAutoFit/>
           </a:bodyPr>
           <a:lstStyle/>
@@ -3241,7 +3253,7 @@
           </a:ln>
         </p:spPr>
         <p:txBody>
-          <a:bodyPr wrap="none" lIns="0" tIns="0" rIns="0" bIns="0" anchor="t" anchorCtr="0">
+          <a:bodyPr wrap="square" lIns="0" tIns="0" rIns="0" bIns="0" anchor="t" anchorCtr="0">
             <a:spAutoFit/>
           </a:bodyPr>
           <a:lstStyle/>
@@ -3281,7 +3293,7 @@
           </a:ln>
         </p:spPr>
         <p:txBody>
-          <a:bodyPr wrap="none" lIns="0" tIns="0" rIns="0" bIns="0" anchor="t" anchorCtr="0">
+          <a:bodyPr wrap="square" lIns="0" tIns="0" rIns="0" bIns="0" anchor="t" anchorCtr="0">
             <a:spAutoFit/>
           </a:bodyPr>
           <a:lstStyle/>
@@ -3312,8 +3324,10 @@
             <a:off x="457200" y="2743200"/>
             <a:ext cx="3352800" cy="762000"/>
           </a:xfrm>
-          <a:prstGeom prst="rect">
-            <a:avLst/>
+          <a:prstGeom prst="roundRect">
+            <a:avLst>
+              <a:gd name="adj" fmla="val 5000"/>
+            </a:avLst>
           </a:prstGeom>
           <a:solidFill>
             <a:srgbClr val="F8F9FA"/>
@@ -3322,6 +3336,10 @@
             <a:noFill/>
           </a:ln>
         </p:spPr>
+        <p:txBody>
+          <a:bodyPr lIns="0" rIns="0" tIns="0" bIns="0" wrap="square"/>
+          <a:p/>
+        </p:txBody>
       </p:sp>
       <p:sp>
         <p:nvSpPr>
@@ -3343,7 +3361,7 @@
           </a:ln>
         </p:spPr>
         <p:txBody>
-          <a:bodyPr wrap="none" lIns="0" tIns="0" rIns="0" bIns="0" anchor="t" anchorCtr="0">
+          <a:bodyPr wrap="square" lIns="0" tIns="0" rIns="0" bIns="0" anchor="t" anchorCtr="0">
             <a:spAutoFit/>
           </a:bodyPr>
           <a:lstStyle/>
@@ -3383,7 +3401,7 @@
           </a:ln>
         </p:spPr>
         <p:txBody>
-          <a:bodyPr wrap="none" lIns="0" tIns="0" rIns="0" bIns="0" anchor="t" anchorCtr="0">
+          <a:bodyPr wrap="square" lIns="0" tIns="0" rIns="0" bIns="0" anchor="t" anchorCtr="0">
             <a:spAutoFit/>
           </a:bodyPr>
           <a:lstStyle/>
@@ -3414,8 +3432,10 @@
             <a:off x="4191000" y="1143000"/>
             <a:ext cx="7543800" cy="4724400"/>
           </a:xfrm>
-          <a:prstGeom prst="rect">
-            <a:avLst/>
+          <a:prstGeom prst="roundRect">
+            <a:avLst>
+              <a:gd name="adj" fmla="val 5000"/>
+            </a:avLst>
           </a:prstGeom>
           <a:solidFill>
             <a:srgbClr val="F8F9FA"/>
@@ -3424,6 +3444,10 @@
             <a:noFill/>
           </a:ln>
         </p:spPr>
+        <p:txBody>
+          <a:bodyPr lIns="0" rIns="0" tIns="0" bIns="0" wrap="square"/>
+          <a:p/>
+        </p:txBody>
       </p:sp>
       <p:sp>
         <p:nvSpPr>
@@ -3472,6 +3496,10 @@
             </a:solidFill>
           </a:ln>
         </p:spPr>
+        <p:txBody>
+          <a:bodyPr lIns="0" rIns="0" tIns="0" bIns="0" wrap="square"/>
+          <a:p/>
+        </p:txBody>
       </p:sp>
       <p:sp>
         <p:nvSpPr>
@@ -3496,6 +3524,10 @@
             <a:noFill/>
           </a:ln>
         </p:spPr>
+        <p:txBody>
+          <a:bodyPr lIns="0" rIns="0" tIns="0" bIns="0" wrap="square"/>
+          <a:p/>
+        </p:txBody>
       </p:sp>
       <p:sp>
         <p:nvSpPr>
@@ -3520,6 +3552,10 @@
             <a:noFill/>
           </a:ln>
         </p:spPr>
+        <p:txBody>
+          <a:bodyPr lIns="0" rIns="0" tIns="0" bIns="0" wrap="square"/>
+          <a:p/>
+        </p:txBody>
       </p:sp>
       <p:sp>
         <p:nvSpPr>
@@ -3544,6 +3580,10 @@
             <a:noFill/>
           </a:ln>
         </p:spPr>
+        <p:txBody>
+          <a:bodyPr lIns="0" rIns="0" tIns="0" bIns="0" wrap="square"/>
+          <a:p/>
+        </p:txBody>
       </p:sp>
       <p:sp>
         <p:nvSpPr>
@@ -3556,8 +3596,10 @@
             <a:off x="4381500" y="5334000"/>
             <a:ext cx="1905000" cy="381000"/>
           </a:xfrm>
-          <a:prstGeom prst="rect">
-            <a:avLst/>
+          <a:prstGeom prst="roundRect">
+            <a:avLst>
+              <a:gd name="adj" fmla="val 5000"/>
+            </a:avLst>
           </a:prstGeom>
           <a:solidFill>
             <a:srgbClr val="FFFFFF"/>
@@ -3566,6 +3608,10 @@
             <a:noFill/>
           </a:ln>
         </p:spPr>
+        <p:txBody>
+          <a:bodyPr lIns="0" rIns="0" tIns="0" bIns="0" wrap="square"/>
+          <a:p/>
+        </p:txBody>
       </p:sp>
       <p:sp>
         <p:nvSpPr>
@@ -3588,6 +3634,10 @@
             <a:noFill/>
           </a:ln>
         </p:spPr>
+        <p:txBody>
+          <a:bodyPr lIns="0" rIns="0" tIns="0" bIns="0" wrap="square"/>
+          <a:p/>
+        </p:txBody>
       </p:sp>
       <p:sp>
         <p:nvSpPr>
@@ -3609,7 +3659,7 @@
           </a:ln>
         </p:spPr>
         <p:txBody>
-          <a:bodyPr wrap="none" lIns="0" tIns="0" rIns="0" bIns="0" anchor="t" anchorCtr="0">
+          <a:bodyPr wrap="square" lIns="0" tIns="0" rIns="0" bIns="0" anchor="t" anchorCtr="0">
             <a:spAutoFit/>
           </a:bodyPr>
           <a:lstStyle/>
@@ -3650,6 +3700,10 @@
             <a:noFill/>
           </a:ln>
         </p:spPr>
+        <p:txBody>
+          <a:bodyPr lIns="0" rIns="0" tIns="0" bIns="0" wrap="square"/>
+          <a:p/>
+        </p:txBody>
       </p:sp>
       <p:sp>
         <p:nvSpPr>
@@ -3671,7 +3725,7 @@
           </a:ln>
         </p:spPr>
         <p:txBody>
-          <a:bodyPr wrap="none" lIns="0" tIns="0" rIns="0" bIns="0" anchor="t" anchorCtr="0">
+          <a:bodyPr wrap="square" lIns="0" tIns="0" rIns="0" bIns="0" anchor="t" anchorCtr="0">
             <a:spAutoFit/>
           </a:bodyPr>
           <a:lstStyle/>
@@ -3711,7 +3765,7 @@
           </a:ln>
         </p:spPr>
         <p:txBody>
-          <a:bodyPr wrap="none" lIns="0" tIns="0" rIns="0" bIns="0" anchor="t" anchorCtr="0">
+          <a:bodyPr wrap="square" lIns="0" tIns="0" rIns="0" bIns="0" anchor="t" anchorCtr="0">
             <a:spAutoFit/>
           </a:bodyPr>
           <a:lstStyle/>
@@ -3767,8 +3821,10 @@
             <a:off x="447675" y="447675"/>
             <a:ext cx="12192000" cy="6858000"/>
           </a:xfrm>
-          <a:prstGeom prst="rect">
-            <a:avLst/>
+          <a:prstGeom prst="roundRect">
+            <a:avLst>
+              <a:gd name="adj" fmla="val 5000"/>
+            </a:avLst>
           </a:prstGeom>
           <a:solidFill>
             <a:srgbClr val="FFFFFF"/>
@@ -3777,6 +3833,10 @@
             <a:noFill/>
           </a:ln>
         </p:spPr>
+        <p:txBody>
+          <a:bodyPr lIns="0" rIns="0" tIns="0" bIns="0" wrap="square"/>
+          <a:p/>
+        </p:txBody>
       </p:sp>
       <p:sp>
         <p:nvSpPr>
@@ -3798,7 +3858,7 @@
           </a:ln>
         </p:spPr>
         <p:txBody>
-          <a:bodyPr wrap="none" lIns="0" tIns="0" rIns="0" bIns="0" anchor="t" anchorCtr="0">
+          <a:bodyPr wrap="square" lIns="0" tIns="0" rIns="0" bIns="0" anchor="t" anchorCtr="0">
             <a:spAutoFit/>
           </a:bodyPr>
           <a:lstStyle/>
@@ -3829,8 +3889,10 @@
             <a:off x="457200" y="1143000"/>
             <a:ext cx="6172200" cy="5257800"/>
           </a:xfrm>
-          <a:prstGeom prst="rect">
-            <a:avLst/>
+          <a:prstGeom prst="roundRect">
+            <a:avLst>
+              <a:gd name="adj" fmla="val 5000"/>
+            </a:avLst>
           </a:prstGeom>
           <a:solidFill>
             <a:srgbClr val="F8F9FA"/>
@@ -3839,6 +3901,10 @@
             <a:noFill/>
           </a:ln>
         </p:spPr>
+        <p:txBody>
+          <a:bodyPr lIns="0" rIns="0" tIns="0" bIns="0" wrap="square"/>
+          <a:p/>
+        </p:txBody>
       </p:sp>
       <p:sp>
         <p:nvSpPr>
@@ -3893,6 +3959,10 @@
             </a:solidFill>
           </a:ln>
         </p:spPr>
+        <p:txBody>
+          <a:bodyPr lIns="0" rIns="0" tIns="0" bIns="0" wrap="square"/>
+          <a:p/>
+        </p:txBody>
       </p:sp>
       <p:sp>
         <p:nvSpPr>
@@ -3915,6 +3985,10 @@
             <a:noFill/>
           </a:ln>
         </p:spPr>
+        <p:txBody>
+          <a:bodyPr lIns="0" rIns="0" tIns="0" bIns="0" wrap="square"/>
+          <a:p/>
+        </p:txBody>
       </p:sp>
       <p:sp>
         <p:nvSpPr>
@@ -3937,6 +4011,10 @@
             <a:noFill/>
           </a:ln>
         </p:spPr>
+        <p:txBody>
+          <a:bodyPr lIns="0" rIns="0" tIns="0" bIns="0" wrap="square"/>
+          <a:p/>
+        </p:txBody>
       </p:sp>
       <p:sp>
         <p:nvSpPr>
@@ -3959,6 +4037,10 @@
             <a:noFill/>
           </a:ln>
         </p:spPr>
+        <p:txBody>
+          <a:bodyPr lIns="0" rIns="0" tIns="0" bIns="0" wrap="square"/>
+          <a:p/>
+        </p:txBody>
       </p:sp>
       <p:sp>
         <p:nvSpPr>
@@ -3971,8 +4053,10 @@
             <a:off x="7010400" y="1143000"/>
             <a:ext cx="4724400" cy="2362200"/>
           </a:xfrm>
-          <a:prstGeom prst="rect">
-            <a:avLst/>
+          <a:prstGeom prst="roundRect">
+            <a:avLst>
+              <a:gd name="adj" fmla="val 5000"/>
+            </a:avLst>
           </a:prstGeom>
           <a:solidFill>
             <a:srgbClr val="F8F9FA"/>
@@ -3981,6 +4065,10 @@
             <a:noFill/>
           </a:ln>
         </p:spPr>
+        <p:txBody>
+          <a:bodyPr lIns="0" rIns="0" tIns="0" bIns="0" wrap="square"/>
+          <a:p/>
+        </p:txBody>
       </p:sp>
       <p:sp>
         <p:nvSpPr>
@@ -4002,7 +4090,7 @@
           </a:ln>
         </p:spPr>
         <p:txBody>
-          <a:bodyPr wrap="none" lIns="0" tIns="0" rIns="0" bIns="0" anchor="t" anchorCtr="0">
+          <a:bodyPr wrap="square" lIns="0" tIns="0" rIns="0" bIns="0" anchor="t" anchorCtr="0">
             <a:spAutoFit/>
           </a:bodyPr>
           <a:lstStyle/>
@@ -4042,7 +4130,7 @@
           </a:ln>
         </p:spPr>
         <p:txBody>
-          <a:bodyPr wrap="none" lIns="0" tIns="0" rIns="0" bIns="0" anchor="t" anchorCtr="0">
+          <a:bodyPr wrap="square" lIns="0" tIns="0" rIns="0" bIns="0" anchor="t" anchorCtr="0">
             <a:spAutoFit/>
           </a:bodyPr>
           <a:lstStyle/>
@@ -4082,7 +4170,7 @@
           </a:ln>
         </p:spPr>
         <p:txBody>
-          <a:bodyPr wrap="none" lIns="0" tIns="0" rIns="0" bIns="0" anchor="t" anchorCtr="0">
+          <a:bodyPr wrap="square" lIns="0" tIns="0" rIns="0" bIns="0" anchor="t" anchorCtr="0">
             <a:spAutoFit/>
           </a:bodyPr>
           <a:lstStyle/>
@@ -4113,8 +4201,10 @@
             <a:off x="7010400" y="3733800"/>
             <a:ext cx="4724400" cy="2667000"/>
           </a:xfrm>
-          <a:prstGeom prst="rect">
-            <a:avLst/>
+          <a:prstGeom prst="roundRect">
+            <a:avLst>
+              <a:gd name="adj" fmla="val 5000"/>
+            </a:avLst>
           </a:prstGeom>
           <a:solidFill>
             <a:srgbClr val="F8F9FA"/>
@@ -4123,6 +4213,10 @@
             <a:noFill/>
           </a:ln>
         </p:spPr>
+        <p:txBody>
+          <a:bodyPr lIns="0" rIns="0" tIns="0" bIns="0" wrap="square"/>
+          <a:p/>
+        </p:txBody>
       </p:sp>
       <p:sp>
         <p:nvSpPr>
@@ -4144,7 +4238,7 @@
           </a:ln>
         </p:spPr>
         <p:txBody>
-          <a:bodyPr wrap="none" lIns="0" tIns="0" rIns="0" bIns="0" anchor="t" anchorCtr="0">
+          <a:bodyPr wrap="square" lIns="0" tIns="0" rIns="0" bIns="0" anchor="t" anchorCtr="0">
             <a:spAutoFit/>
           </a:bodyPr>
           <a:lstStyle/>
@@ -4185,6 +4279,10 @@
             <a:noFill/>
           </a:ln>
         </p:spPr>
+        <p:txBody>
+          <a:bodyPr lIns="0" rIns="0" tIns="0" bIns="0" wrap="square"/>
+          <a:p/>
+        </p:txBody>
       </p:sp>
       <p:sp>
         <p:nvSpPr>
@@ -4206,7 +4304,7 @@
           </a:ln>
         </p:spPr>
         <p:txBody>
-          <a:bodyPr wrap="none" lIns="0" tIns="0" rIns="0" bIns="0" anchor="t" anchorCtr="0">
+          <a:bodyPr wrap="square" lIns="0" tIns="0" rIns="0" bIns="0" anchor="t" anchorCtr="0">
             <a:spAutoFit/>
           </a:bodyPr>
           <a:lstStyle/>
@@ -4246,7 +4344,7 @@
           </a:ln>
         </p:spPr>
         <p:txBody>
-          <a:bodyPr wrap="none" lIns="0" tIns="0" rIns="0" bIns="0" anchor="t" anchorCtr="0">
+          <a:bodyPr wrap="square" lIns="0" tIns="0" rIns="0" bIns="0" anchor="t" anchorCtr="0">
             <a:spAutoFit/>
           </a:bodyPr>
           <a:lstStyle/>
@@ -4287,6 +4385,10 @@
             <a:noFill/>
           </a:ln>
         </p:spPr>
+        <p:txBody>
+          <a:bodyPr lIns="0" rIns="0" tIns="0" bIns="0" wrap="square"/>
+          <a:p/>
+        </p:txBody>
       </p:sp>
       <p:sp>
         <p:nvSpPr>
@@ -4308,7 +4410,7 @@
           </a:ln>
         </p:spPr>
         <p:txBody>
-          <a:bodyPr wrap="none" lIns="0" tIns="0" rIns="0" bIns="0" anchor="t" anchorCtr="0">
+          <a:bodyPr wrap="square" lIns="0" tIns="0" rIns="0" bIns="0" anchor="t" anchorCtr="0">
             <a:spAutoFit/>
           </a:bodyPr>
           <a:lstStyle/>
@@ -4348,7 +4450,7 @@
           </a:ln>
         </p:spPr>
         <p:txBody>
-          <a:bodyPr wrap="none" lIns="0" tIns="0" rIns="0" bIns="0" anchor="t" anchorCtr="0">
+          <a:bodyPr wrap="square" lIns="0" tIns="0" rIns="0" bIns="0" anchor="t" anchorCtr="0">
             <a:spAutoFit/>
           </a:bodyPr>
           <a:lstStyle/>
@@ -4389,6 +4491,10 @@
             <a:noFill/>
           </a:ln>
         </p:spPr>
+        <p:txBody>
+          <a:bodyPr lIns="0" rIns="0" tIns="0" bIns="0" wrap="square"/>
+          <a:p/>
+        </p:txBody>
       </p:sp>
       <p:sp>
         <p:nvSpPr>
@@ -4410,7 +4516,7 @@
           </a:ln>
         </p:spPr>
         <p:txBody>
-          <a:bodyPr wrap="none" lIns="0" tIns="0" rIns="0" bIns="0" anchor="t" anchorCtr="0">
+          <a:bodyPr wrap="square" lIns="0" tIns="0" rIns="0" bIns="0" anchor="t" anchorCtr="0">
             <a:spAutoFit/>
           </a:bodyPr>
           <a:lstStyle/>
@@ -4450,7 +4556,7 @@
           </a:ln>
         </p:spPr>
         <p:txBody>
-          <a:bodyPr wrap="none" lIns="0" tIns="0" rIns="0" bIns="0" anchor="t" anchorCtr="0">
+          <a:bodyPr wrap="square" lIns="0" tIns="0" rIns="0" bIns="0" anchor="t" anchorCtr="0">
             <a:spAutoFit/>
           </a:bodyPr>
           <a:lstStyle/>
@@ -4506,8 +4612,10 @@
             <a:off x="447675" y="447675"/>
             <a:ext cx="12192000" cy="6858000"/>
           </a:xfrm>
-          <a:prstGeom prst="rect">
-            <a:avLst/>
+          <a:prstGeom prst="roundRect">
+            <a:avLst>
+              <a:gd name="adj" fmla="val 5000"/>
+            </a:avLst>
           </a:prstGeom>
           <a:solidFill>
             <a:srgbClr val="FFFFFF"/>
@@ -4516,6 +4624,10 @@
             <a:noFill/>
           </a:ln>
         </p:spPr>
+        <p:txBody>
+          <a:bodyPr lIns="0" rIns="0" tIns="0" bIns="0" wrap="square"/>
+          <a:p/>
+        </p:txBody>
       </p:sp>
       <p:sp>
         <p:nvSpPr>
@@ -4537,7 +4649,7 @@
           </a:ln>
         </p:spPr>
         <p:txBody>
-          <a:bodyPr wrap="none" lIns="0" tIns="0" rIns="0" bIns="0" anchor="t" anchorCtr="0">
+          <a:bodyPr wrap="square" lIns="0" tIns="0" rIns="0" bIns="0" anchor="t" anchorCtr="0">
             <a:spAutoFit/>
           </a:bodyPr>
           <a:lstStyle/>
@@ -4568,8 +4680,10 @@
             <a:off x="457200" y="1371600"/>
             <a:ext cx="3429000" cy="2133600"/>
           </a:xfrm>
-          <a:prstGeom prst="rect">
-            <a:avLst/>
+          <a:prstGeom prst="roundRect">
+            <a:avLst>
+              <a:gd name="adj" fmla="val 5000"/>
+            </a:avLst>
           </a:prstGeom>
           <a:solidFill>
             <a:srgbClr val="F8F9FA"/>
@@ -4578,6 +4692,10 @@
             <a:noFill/>
           </a:ln>
         </p:spPr>
+        <p:txBody>
+          <a:bodyPr lIns="0" rIns="0" tIns="0" bIns="0" wrap="square"/>
+          <a:p/>
+        </p:txBody>
       </p:sp>
       <p:sp>
         <p:nvSpPr>
@@ -4599,7 +4717,7 @@
           </a:ln>
         </p:spPr>
         <p:txBody>
-          <a:bodyPr wrap="none" lIns="0" tIns="0" rIns="0" bIns="0" anchor="t" anchorCtr="0">
+          <a:bodyPr wrap="square" lIns="0" tIns="0" rIns="0" bIns="0" anchor="t" anchorCtr="0">
             <a:spAutoFit/>
           </a:bodyPr>
           <a:lstStyle/>
@@ -4639,7 +4757,7 @@
           </a:ln>
         </p:spPr>
         <p:txBody>
-          <a:bodyPr wrap="none" lIns="0" tIns="0" rIns="0" bIns="0" anchor="t" anchorCtr="0">
+          <a:bodyPr wrap="square" lIns="0" tIns="0" rIns="0" bIns="0" anchor="t" anchorCtr="0">
             <a:spAutoFit/>
           </a:bodyPr>
           <a:lstStyle/>
@@ -4679,7 +4797,7 @@
           </a:ln>
         </p:spPr>
         <p:txBody>
-          <a:bodyPr wrap="none" lIns="0" tIns="0" rIns="0" bIns="0" anchor="t" anchorCtr="0">
+          <a:bodyPr wrap="square" lIns="0" tIns="0" rIns="0" bIns="0" anchor="t" anchorCtr="0">
             <a:spAutoFit/>
           </a:bodyPr>
           <a:lstStyle/>
@@ -4742,6 +4860,10 @@
             </a:solidFill>
           </a:ln>
         </p:spPr>
+        <p:txBody>
+          <a:bodyPr lIns="0" rIns="0" tIns="0" bIns="0" wrap="square"/>
+          <a:p/>
+        </p:txBody>
       </p:sp>
       <p:sp>
         <p:nvSpPr>
@@ -4754,8 +4876,10 @@
             <a:off x="4419600" y="1371600"/>
             <a:ext cx="3429000" cy="2133600"/>
           </a:xfrm>
-          <a:prstGeom prst="rect">
-            <a:avLst/>
+          <a:prstGeom prst="roundRect">
+            <a:avLst>
+              <a:gd name="adj" fmla="val 5000"/>
+            </a:avLst>
           </a:prstGeom>
           <a:solidFill>
             <a:srgbClr val="F8F9FA"/>
@@ -4764,6 +4888,10 @@
             <a:noFill/>
           </a:ln>
         </p:spPr>
+        <p:txBody>
+          <a:bodyPr lIns="0" rIns="0" tIns="0" bIns="0" wrap="square"/>
+          <a:p/>
+        </p:txBody>
       </p:sp>
       <p:sp>
         <p:nvSpPr>
@@ -4785,7 +4913,7 @@
           </a:ln>
         </p:spPr>
         <p:txBody>
-          <a:bodyPr wrap="none" lIns="0" tIns="0" rIns="0" bIns="0" anchor="t" anchorCtr="0">
+          <a:bodyPr wrap="square" lIns="0" tIns="0" rIns="0" bIns="0" anchor="t" anchorCtr="0">
             <a:spAutoFit/>
           </a:bodyPr>
           <a:lstStyle/>
@@ -4825,7 +4953,7 @@
           </a:ln>
         </p:spPr>
         <p:txBody>
-          <a:bodyPr wrap="none" lIns="0" tIns="0" rIns="0" bIns="0" anchor="t" anchorCtr="0">
+          <a:bodyPr wrap="square" lIns="0" tIns="0" rIns="0" bIns="0" anchor="t" anchorCtr="0">
             <a:spAutoFit/>
           </a:bodyPr>
           <a:lstStyle/>
@@ -4865,7 +4993,7 @@
           </a:ln>
         </p:spPr>
         <p:txBody>
-          <a:bodyPr wrap="none" lIns="0" tIns="0" rIns="0" bIns="0" anchor="t" anchorCtr="0">
+          <a:bodyPr wrap="square" lIns="0" tIns="0" rIns="0" bIns="0" anchor="t" anchorCtr="0">
             <a:spAutoFit/>
           </a:bodyPr>
           <a:lstStyle/>
@@ -4906,6 +5034,10 @@
             </a:solidFill>
           </a:ln>
         </p:spPr>
+        <p:txBody>
+          <a:bodyPr lIns="0" rIns="0" tIns="0" bIns="0" wrap="square"/>
+          <a:p/>
+        </p:txBody>
       </p:sp>
       <p:sp>
         <p:nvSpPr>
@@ -4928,6 +5060,10 @@
             </a:solidFill>
           </a:ln>
         </p:spPr>
+        <p:txBody>
+          <a:bodyPr lIns="0" rIns="0" tIns="0" bIns="0" wrap="square"/>
+          <a:p/>
+        </p:txBody>
       </p:sp>
       <p:sp>
         <p:nvSpPr>
@@ -4940,8 +5076,10 @@
             <a:off x="8305800" y="1371600"/>
             <a:ext cx="3429000" cy="2133600"/>
           </a:xfrm>
-          <a:prstGeom prst="rect">
-            <a:avLst/>
+          <a:prstGeom prst="roundRect">
+            <a:avLst>
+              <a:gd name="adj" fmla="val 5000"/>
+            </a:avLst>
           </a:prstGeom>
           <a:solidFill>
             <a:srgbClr val="F8F9FA"/>
@@ -4950,6 +5088,10 @@
             <a:noFill/>
           </a:ln>
         </p:spPr>
+        <p:txBody>
+          <a:bodyPr lIns="0" rIns="0" tIns="0" bIns="0" wrap="square"/>
+          <a:p/>
+        </p:txBody>
       </p:sp>
       <p:sp>
         <p:nvSpPr>
@@ -4971,7 +5113,7 @@
           </a:ln>
         </p:spPr>
         <p:txBody>
-          <a:bodyPr wrap="none" lIns="0" tIns="0" rIns="0" bIns="0" anchor="t" anchorCtr="0">
+          <a:bodyPr wrap="square" lIns="0" tIns="0" rIns="0" bIns="0" anchor="t" anchorCtr="0">
             <a:spAutoFit/>
           </a:bodyPr>
           <a:lstStyle/>
@@ -5011,7 +5153,7 @@
           </a:ln>
         </p:spPr>
         <p:txBody>
-          <a:bodyPr wrap="none" lIns="0" tIns="0" rIns="0" bIns="0" anchor="t" anchorCtr="0">
+          <a:bodyPr wrap="square" lIns="0" tIns="0" rIns="0" bIns="0" anchor="t" anchorCtr="0">
             <a:spAutoFit/>
           </a:bodyPr>
           <a:lstStyle/>
@@ -5042,8 +5184,10 @@
             <a:off x="8543925" y="2381250"/>
             <a:ext cx="381000" cy="381000"/>
           </a:xfrm>
-          <a:prstGeom prst="rect">
-            <a:avLst/>
+          <a:prstGeom prst="roundRect">
+            <a:avLst>
+              <a:gd name="adj" fmla="val 5000"/>
+            </a:avLst>
           </a:prstGeom>
           <a:solidFill>
             <a:srgbClr val="E1EFFF"/>
@@ -5052,6 +5196,10 @@
             <a:noFill/>
           </a:ln>
         </p:spPr>
+        <p:txBody>
+          <a:bodyPr lIns="0" rIns="0" tIns="0" bIns="0" wrap="square"/>
+          <a:p/>
+        </p:txBody>
       </p:sp>
       <p:sp>
         <p:nvSpPr>
@@ -5102,6 +5250,10 @@
             </a:solidFill>
           </a:ln>
         </p:spPr>
+        <p:txBody>
+          <a:bodyPr lIns="0" rIns="0" tIns="0" bIns="0" wrap="square"/>
+          <a:p/>
+        </p:txBody>
       </p:sp>
       <p:sp>
         <p:nvSpPr>
@@ -5123,7 +5275,7 @@
           </a:ln>
         </p:spPr>
         <p:txBody>
-          <a:bodyPr wrap="none" lIns="0" tIns="0" rIns="0" bIns="0" anchor="t" anchorCtr="0">
+          <a:bodyPr wrap="square" lIns="0" tIns="0" rIns="0" bIns="0" anchor="t" anchorCtr="0">
             <a:spAutoFit/>
           </a:bodyPr>
           <a:lstStyle/>

</xml_diff>